<commit_message>
Update B2B PL slides to KPI report of 25.08.2026, FY27 target 900k
Numbers are now driven by KPI/PANEL constants in build_slides.js so new
panel orders after 25.08 can be added and totals recomputed.

Co-Authored-By: Claude Opus 5.5 <noreply@anthropic.com>
Claude-Session: https://claude.ai/code/session_01X3b4nN4VQ8Ge4ucA4qFPyi
</commit_message>
<xml_diff>
--- a/B2B_PL_kickoff_FY27_2_slajdy.pptx
+++ b/B2B_PL_kickoff_FY27_2_slajdy.pptx
@@ -503,7 +503,7 @@
           <a:p>
             <a:r>
               <a:rPr lang="en-US" dirty="0"/>
-              <a:t>Jeden slajd zamiast 9–14. Plan zakładał 166 kont i 928 zamówień. Platforma przyjęła się (cała baza jest na niej, 2/3 budżetu sprzedaży), ale klienci zamawiają rzadko i dużo. Wnioski na FY27: aktywacja zamiast samej rejestracji, automatyczna komunikacja, częstotliwość zamówień, nowe sklepy z lead genu.</a:t>
+              <a:t>Jeden slajd zamiast 9–14. Plan zakładał 166 kont i 928 zamówień. Platforma przyjęła się (174 kont, 86% budżetu sprzedaży, przed planem do dziś), ale klienci zamawiają rzadko i dużo (308 zamówień = 33% celu).  Wnioski na FY27: aktywacja zamiast samej rejestracji, automatyczna komunikacja, częstotliwość zamówień, nowe sklepy z lead genu.</a:t>
             </a:r>
             <a:endParaRPr lang="en-US" dirty="0"/>
           </a:p>
@@ -591,7 +591,7 @@
           <a:p>
             <a:r>
               <a:rPr lang="en-US" dirty="0"/>
-              <a:t>Wynik: 2/3 budżetu sprzedaży i 2/3 bazy z zamówieniem, ale tylko 21% zamówień. Średnie zamówienie ponad 3× plan, bo klienci robią duże zamówienia na stock. Nowy panel odpowiada na te wnioski: ceny i rabaty liczone od razu w koszyku, kredyt kupiecki zamiast przedpłaty, rabat za krótszy termin płatności, automatyczne maile onboardingowe. Cele FY27: 900 tys. €, 1 125 zamówień.</a:t>
+              <a:t>Wynik na 25.08.2026: 86% budżetu sprzedaży (105% planu do dziś), 73% kont z zamówieniem, ale tylko 33% celu zamówień. Średnie zamówienie 2,6× plan, bo klienci robią duże zamówienia na stock.  Nowy panel odpowiada na te wnioski: ceny i rabaty liczone od razu w koszyku, kredyt kupiecki zamiast przedpłaty, rabat za krótszy termin płatności, automatyczne maile onboardingowe. Cele FY27: 900 tys. €, 1 125 zamówień.</a:t>
             </a:r>
             <a:endParaRPr lang="en-US" dirty="0"/>
           </a:p>
@@ -1555,7 +1555,7 @@
                 <a:ea typeface="Calibri" pitchFamily="34" charset="-122"/>
                 <a:cs typeface="Calibri" pitchFamily="34" charset="-120"/>
               </a:rPr>
-              <a:t>Cała baza na platformie: 166 kont (100%)</a:t>
+              <a:t>174 kont na platformie = 105% założonej bazy</a:t>
             </a:r>
             <a:endParaRPr lang="en-US" sz="1300" dirty="0"/>
           </a:p>
@@ -1576,7 +1576,7 @@
                 <a:ea typeface="Calibri" pitchFamily="34" charset="-122"/>
                 <a:cs typeface="Calibri" pitchFamily="34" charset="-120"/>
               </a:rPr>
-              <a:t>311,6 tys. € sprzedaży = 67% budżetu</a:t>
+              <a:t>396,8 tys. € sprzedaży = 86% budżetu, 105% planu do dziś</a:t>
             </a:r>
             <a:endParaRPr lang="en-US" sz="1300" dirty="0"/>
           </a:p>
@@ -1597,7 +1597,7 @@
                 <a:ea typeface="Calibri" pitchFamily="34" charset="-122"/>
                 <a:cs typeface="Calibri" pitchFamily="34" charset="-120"/>
               </a:rPr>
-              <a:t>Średnie zamówienie 1 574 € (ponad 3× plan)</a:t>
+              <a:t>Średnie zamówienie 1 288 € (2,6× plan)</a:t>
             </a:r>
             <a:endParaRPr lang="en-US" sz="1300" dirty="0"/>
           </a:p>
@@ -1755,7 +1755,7 @@
                 <a:ea typeface="Calibri" pitchFamily="34" charset="-122"/>
                 <a:cs typeface="Calibri" pitchFamily="34" charset="-120"/>
               </a:rPr>
-              <a:t>198 zamówień = 21% celu: rzadkie, duże zamówienia „na stock”</a:t>
+              <a:t>308 zamówień = 33% celu: rzadkie, duże zamówienia „na stock”</a:t>
             </a:r>
             <a:endParaRPr lang="en-US" sz="1300" dirty="0"/>
           </a:p>
@@ -1776,7 +1776,7 @@
                 <a:ea typeface="Calibri" pitchFamily="34" charset="-122"/>
                 <a:cs typeface="Calibri" pitchFamily="34" charset="-120"/>
               </a:rPr>
-              <a:t>55 kont bez żadnego zamówienia</a:t>
+              <a:t>47 kont bez żadnego zamówienia</a:t>
             </a:r>
             <a:endParaRPr lang="en-US" sz="1300" dirty="0"/>
           </a:p>
@@ -2385,7 +2385,7 @@
                 <a:ea typeface="Calibri" pitchFamily="34" charset="-122"/>
                 <a:cs typeface="Calibri" pitchFamily="34" charset="-120"/>
               </a:rPr>
-              <a:t>Wynik FY26 YTD vs budżet</a:t>
+              <a:t>Wynik FY26 vs budżet · stan na 25.08.2026</a:t>
             </a:r>
             <a:endParaRPr lang="en-US" sz="1600" dirty="0"/>
           </a:p>
@@ -2424,7 +2424,7 @@
                 <a:ea typeface="Calibri" pitchFamily="34" charset="-122"/>
                 <a:cs typeface="Calibri" pitchFamily="34" charset="-120"/>
               </a:rPr>
-              <a:t>311 557 €</a:t>
+              <a:t>396 757 €</a:t>
             </a:r>
             <a:endParaRPr lang="en-US" sz="2800" dirty="0"/>
           </a:p>
@@ -2505,7 +2505,7 @@
         <p:spPr>
           <a:xfrm>
             <a:off x="3246120" y="1901952"/>
-            <a:ext cx="1840687" cy="237744"/>
+            <a:ext cx="2345655" cy="237744"/>
           </a:xfrm>
           <a:prstGeom prst="roundRect">
             <a:avLst>
@@ -2556,7 +2556,7 @@
                 <a:ea typeface="Calibri" pitchFamily="34" charset="-122"/>
                 <a:cs typeface="Calibri" pitchFamily="34" charset="-120"/>
               </a:rPr>
-              <a:t>67%</a:t>
+              <a:t>86%</a:t>
             </a:r>
             <a:endParaRPr lang="en-US" sz="1600" dirty="0"/>
           </a:p>
@@ -2571,7 +2571,7 @@
         <p:spPr>
           <a:xfrm>
             <a:off x="3246120" y="2176272"/>
-            <a:ext cx="2743200" cy="256032"/>
+            <a:ext cx="3566160" cy="256032"/>
           </a:xfrm>
           <a:prstGeom prst="rect">
             <a:avLst/>
@@ -2595,7 +2595,7 @@
                 <a:ea typeface="Calibri" pitchFamily="34" charset="-122"/>
                 <a:cs typeface="Calibri" pitchFamily="34" charset="-120"/>
               </a:rPr>
-              <a:t>budżet 464 000 €</a:t>
+              <a:t>budżet 464 000 € · 105% planu do dziś</a:t>
             </a:r>
             <a:endParaRPr lang="en-US" sz="1100" dirty="0"/>
           </a:p>
@@ -2634,7 +2634,7 @@
                 <a:ea typeface="Calibri" pitchFamily="34" charset="-122"/>
                 <a:cs typeface="Calibri" pitchFamily="34" charset="-120"/>
               </a:rPr>
-              <a:t>111 / 166</a:t>
+              <a:t>127 / 174</a:t>
             </a:r>
             <a:endParaRPr lang="en-US" sz="2800" dirty="0"/>
           </a:p>
@@ -2715,7 +2715,7 @@
         <p:spPr>
           <a:xfrm>
             <a:off x="3246120" y="2816352"/>
-            <a:ext cx="1835201" cy="237744"/>
+            <a:ext cx="2002221" cy="237744"/>
           </a:xfrm>
           <a:prstGeom prst="roundRect">
             <a:avLst>
@@ -2766,7 +2766,7 @@
                 <a:ea typeface="Calibri" pitchFamily="34" charset="-122"/>
                 <a:cs typeface="Calibri" pitchFamily="34" charset="-120"/>
               </a:rPr>
-              <a:t>67%</a:t>
+              <a:t>73%</a:t>
             </a:r>
             <a:endParaRPr lang="en-US" sz="1600" dirty="0"/>
           </a:p>
@@ -2781,7 +2781,7 @@
         <p:spPr>
           <a:xfrm>
             <a:off x="3246120" y="3090672"/>
-            <a:ext cx="2743200" cy="256032"/>
+            <a:ext cx="3566160" cy="256032"/>
           </a:xfrm>
           <a:prstGeom prst="rect">
             <a:avLst/>
@@ -2805,7 +2805,7 @@
                 <a:ea typeface="Calibri" pitchFamily="34" charset="-122"/>
                 <a:cs typeface="Calibri" pitchFamily="34" charset="-120"/>
               </a:rPr>
-              <a:t>55 kont uśpionych</a:t>
+              <a:t>47 kont bez zamówienia</a:t>
             </a:r>
             <a:endParaRPr lang="en-US" sz="1100" dirty="0"/>
           </a:p>
@@ -2844,7 +2844,7 @@
                 <a:ea typeface="Calibri" pitchFamily="34" charset="-122"/>
                 <a:cs typeface="Calibri" pitchFamily="34" charset="-120"/>
               </a:rPr>
-              <a:t>198</a:t>
+              <a:t>308</a:t>
             </a:r>
             <a:endParaRPr lang="en-US" sz="2800" dirty="0"/>
           </a:p>
@@ -2925,7 +2925,7 @@
         <p:spPr>
           <a:xfrm>
             <a:off x="3246120" y="3730752"/>
-            <a:ext cx="584302" cy="237744"/>
+            <a:ext cx="910459" cy="237744"/>
           </a:xfrm>
           <a:prstGeom prst="roundRect">
             <a:avLst>
@@ -2976,7 +2976,7 @@
                 <a:ea typeface="Calibri" pitchFamily="34" charset="-122"/>
                 <a:cs typeface="Calibri" pitchFamily="34" charset="-120"/>
               </a:rPr>
-              <a:t>21%</a:t>
+              <a:t>33%</a:t>
             </a:r>
             <a:endParaRPr lang="en-US" sz="1600" dirty="0"/>
           </a:p>
@@ -2991,7 +2991,7 @@
         <p:spPr>
           <a:xfrm>
             <a:off x="3246120" y="4005072"/>
-            <a:ext cx="2743200" cy="256032"/>
+            <a:ext cx="3566160" cy="256032"/>
           </a:xfrm>
           <a:prstGeom prst="rect">
             <a:avLst/>
@@ -3054,7 +3054,7 @@
                 <a:ea typeface="Calibri" pitchFamily="34" charset="-122"/>
                 <a:cs typeface="Calibri" pitchFamily="34" charset="-120"/>
               </a:rPr>
-              <a:t>1 574 €</a:t>
+              <a:t>1 288 €</a:t>
             </a:r>
             <a:endParaRPr lang="en-US" sz="2800" dirty="0"/>
           </a:p>
@@ -3186,7 +3186,7 @@
                 <a:ea typeface="Calibri" pitchFamily="34" charset="-122"/>
                 <a:cs typeface="Calibri" pitchFamily="34" charset="-120"/>
               </a:rPr>
-              <a:t>315%</a:t>
+              <a:t>258%</a:t>
             </a:r>
             <a:endParaRPr lang="en-US" sz="1600" dirty="0"/>
           </a:p>
@@ -3201,7 +3201,7 @@
         <p:spPr>
           <a:xfrm>
             <a:off x="3246120" y="4919472"/>
-            <a:ext cx="2743200" cy="256032"/>
+            <a:ext cx="3566160" cy="256032"/>
           </a:xfrm>
           <a:prstGeom prst="rect">
             <a:avLst/>
@@ -3225,7 +3225,7 @@
                 <a:ea typeface="Calibri" pitchFamily="34" charset="-122"/>
                 <a:cs typeface="Calibri" pitchFamily="34" charset="-120"/>
               </a:rPr>
-              <a:t>plan 500 €</a:t>
+              <a:t>plan 500 €</a:t>
             </a:r>
             <a:endParaRPr lang="en-US" sz="1100" dirty="0"/>
           </a:p>
@@ -3849,7 +3849,7 @@
                 <a:ea typeface="Calibri" pitchFamily="34" charset="-122"/>
                 <a:cs typeface="Calibri" pitchFamily="34" charset="-120"/>
               </a:rPr>
-              <a:t>Dane: raport KPI B2B, FY26 YTD (Power BI, WEB-B2B). Panel: funkcje na podstawie testów, wrzesień 2026.</a:t>
+              <a:t>Dane: raport KPI B2B z 25.08.2026 (Sage ZORDDET, WEB-B2B, narastająco). Nowy panel: funkcje na podstawie testów, wrzesień 2026.</a:t>
             </a:r>
             <a:endParaRPr lang="en-US" sz="1000" dirty="0"/>
           </a:p>

</xml_diff>

<commit_message>
Restyle B2B PL slides to match CEE kick-off deck and use its B2B content
Co-Authored-By: Claude Opus 5.5 <noreply@anthropic.com>
Claude-Session: https://claude.ai/code/session_01X3b4nN4VQ8Ge4ucA4qFPyi
</commit_message>
<xml_diff>
--- a/B2B_PL_kickoff_FY27_2_slajdy.pptx
+++ b/B2B_PL_kickoff_FY27_2_slajdy.pptx
@@ -503,7 +503,7 @@
           <a:p>
             <a:r>
               <a:rPr lang="en-US" dirty="0"/>
-              <a:t>Jeden slajd zamiast 9–14. Plan zakładał 166 kont i 928 zamówień. Platforma przyjęła się (174 kont, 86% budżetu sprzedaży, przed planem do dziś), ale klienci zamawiają rzadko i dużo (308 zamówień = 33% celu).  Wnioski na FY27: aktywacja zamiast samej rejestracji, automatyczna komunikacja, częstotliwość zamówień, nowe sklepy z lead genu.</a:t>
+              <a:t>Jeden slajd zamiast angielskich slajdów o panelu B2B. Założenia z business case FY26: 166 klientów, 928 zamówień, 464 tys. €. Panel się przyjął: 174 kont, 86% budżetu sprzedaży i przed planem do dziś, 59% klientów wraca z drugim zamówieniem. Słabo z liczbą zamówień (308 = 33% celu): klienci zamawiają rzadko i dużo, bez kampanii, bez kontaktu w sezonie, a korekty cen w Sage nie wracały do panelu. Stąd 4 learningi na FY27.</a:t>
             </a:r>
             <a:endParaRPr lang="en-US" dirty="0"/>
           </a:p>
@@ -591,7 +591,7 @@
           <a:p>
             <a:r>
               <a:rPr lang="en-US" dirty="0"/>
-              <a:t>Wynik na 25.08.2026: 86% budżetu sprzedaży (105% planu do dziś), 73% kont z zamówieniem, ale tylko 33% celu zamówień. Średnie zamówienie 2,6× plan, bo klienci robią duże zamówienia na stock.  Nowy panel odpowiada na te wnioski: ceny i rabaty liczone od razu w koszyku, kredyt kupiecki zamiast przedpłaty, rabat za krótszy termin płatności, automatyczne maile onboardingowe. Cele FY27: 900 tys. €, 1 125 zamówień.</a:t>
+              <a:t>Wynik na 25.08.2026: 86% budżetu sprzedaży (105% planu do dziś), 73% kont z zamówieniem, ale tylko 33% celu zamówień. Średnie zamówienie 2,6× plan, bo klienci zamawiają rzadko i dużo. 1 października startuje nowa platforma: ceny i rabaty od razu w koszyku, kredyt kupiecki, rabat za krótszy termin płatności, automatyczne maile i program partnerski. Cele FY27: 900 tys. €, 1 125 zamówień.</a:t>
             </a:r>
             <a:endParaRPr lang="en-US" dirty="0"/>
           </a:p>
@@ -972,8 +972,8 @@
         </p:nvSpPr>
         <p:spPr>
           <a:xfrm>
-            <a:off x="457200" y="320040"/>
-            <a:ext cx="11247120" cy="685800"/>
+            <a:off x="411480" y="274320"/>
+            <a:ext cx="11338560" cy="731520"/>
           </a:xfrm>
           <a:prstGeom prst="rect">
             <a:avLst/>
@@ -989,17 +989,17 @@
               <a:buNone/>
             </a:pPr>
             <a:r>
-              <a:rPr lang="en-US" sz="2800" b="1" dirty="0">
-                <a:solidFill>
-                  <a:srgbClr val="1F4E3D"/>
-                </a:solidFill>
-                <a:latin typeface="Cambria" pitchFamily="34" charset="0"/>
-                <a:ea typeface="Cambria" pitchFamily="34" charset="-122"/>
-                <a:cs typeface="Cambria" pitchFamily="34" charset="-120"/>
-              </a:rPr>
-              <a:t>B2B PL: założenia, realizacja, learningi na FY27</a:t>
-            </a:r>
-            <a:endParaRPr lang="en-US" sz="2800" dirty="0"/>
+              <a:rPr lang="en-US" sz="4000" b="1" dirty="0">
+                <a:solidFill>
+                  <a:srgbClr val="108C96"/>
+                </a:solidFill>
+                <a:latin typeface="Calibri" pitchFamily="34" charset="0"/>
+                <a:ea typeface="Calibri" pitchFamily="34" charset="-122"/>
+                <a:cs typeface="Calibri" pitchFamily="34" charset="-120"/>
+              </a:rPr>
+              <a:t>B2B PL – PODSUMOWANIE FY26</a:t>
+            </a:r>
+            <a:endParaRPr lang="en-US" sz="4000" dirty="0"/>
           </a:p>
         </p:txBody>
       </p:sp>
@@ -1011,53 +1011,26 @@
         </p:nvSpPr>
         <p:spPr>
           <a:xfrm>
-            <a:off x="457200" y="1234440"/>
-            <a:ext cx="2647188" cy="3154680"/>
-          </a:xfrm>
-          <a:prstGeom prst="roundRect">
-            <a:avLst>
-              <a:gd name="adj" fmla="val 2763"/>
-            </a:avLst>
-          </a:prstGeom>
-          <a:solidFill>
-            <a:srgbClr val="EEF4F0"/>
+            <a:off x="411480" y="1188720"/>
+            <a:ext cx="2697480" cy="457200"/>
+          </a:xfrm>
+          <a:prstGeom prst="rect">
+            <a:avLst/>
+          </a:prstGeom>
+          <a:solidFill>
+            <a:srgbClr val="174769"/>
           </a:solidFill>
           <a:ln w="12700">
             <a:solidFill>
-              <a:srgbClr val="EEF4F0"/>
+              <a:srgbClr val="174769"/>
             </a:solidFill>
             <a:prstDash val="solid"/>
           </a:ln>
         </p:spPr>
       </p:sp>
-      <p:sp>
-        <p:nvSpPr>
-          <p:cNvPr id="4" name="Shape 2"/>
-          <p:cNvSpPr/>
-          <p:nvPr/>
-        </p:nvSpPr>
-        <p:spPr>
-          <a:xfrm>
-            <a:off x="685800" y="1463040"/>
-            <a:ext cx="502920" cy="502920"/>
-          </a:xfrm>
-          <a:prstGeom prst="ellipse">
-            <a:avLst/>
-          </a:prstGeom>
-          <a:solidFill>
-            <a:srgbClr val="FFFFFF"/>
-          </a:solidFill>
-          <a:ln w="19050">
-            <a:solidFill>
-              <a:srgbClr val="2E7D5B"/>
-            </a:solidFill>
-            <a:prstDash val="solid"/>
-          </a:ln>
-        </p:spPr>
-      </p:sp>
       <p:pic>
         <p:nvPicPr>
-          <p:cNvPr id="5" name="Image 0" descr="preencoded.png">    </p:cNvPr>
+          <p:cNvPr id="4" name="Image 0" descr="preencoded.png">    </p:cNvPr>
           <p:cNvPicPr>
             <a:picLocks noChangeAspect="1"/>
           </p:cNvPicPr>
@@ -1071,8 +1044,8 @@
         </p:blipFill>
         <p:spPr>
           <a:xfrm>
-            <a:off x="809244" y="1586484"/>
-            <a:ext cx="256032" cy="256032"/>
+            <a:off x="576072" y="1307592"/>
+            <a:ext cx="219456" cy="219456"/>
           </a:xfrm>
           <a:prstGeom prst="rect">
             <a:avLst/>
@@ -1081,14 +1054,14 @@
       </p:pic>
       <p:sp>
         <p:nvSpPr>
-          <p:cNvPr id="6" name="Text 3"/>
-          <p:cNvSpPr txBox="1"/>
-          <p:nvPr/>
-        </p:nvSpPr>
-        <p:spPr>
-          <a:xfrm>
-            <a:off x="1325880" y="1463040"/>
-            <a:ext cx="1641348" cy="502920"/>
+          <p:cNvPr id="5" name="Text 2"/>
+          <p:cNvSpPr txBox="1"/>
+          <p:nvPr/>
+        </p:nvSpPr>
+        <p:spPr>
+          <a:xfrm>
+            <a:off x="886968" y="1188720"/>
+            <a:ext cx="2148840" cy="457200"/>
           </a:xfrm>
           <a:prstGeom prst="rect">
             <a:avLst/>
@@ -1106,13 +1079,13 @@
             <a:r>
               <a:rPr lang="en-US" sz="1600" b="1" dirty="0">
                 <a:solidFill>
-                  <a:srgbClr val="1F4E3D"/>
-                </a:solidFill>
-                <a:latin typeface="Calibri" pitchFamily="34" charset="0"/>
-                <a:ea typeface="Calibri" pitchFamily="34" charset="-122"/>
-                <a:cs typeface="Calibri" pitchFamily="34" charset="-120"/>
-              </a:rPr>
-              <a:t>Założenia FY26</a:t>
+                  <a:srgbClr val="FFFFFF"/>
+                </a:solidFill>
+                <a:latin typeface="Calibri" pitchFamily="34" charset="0"/>
+                <a:ea typeface="Calibri" pitchFamily="34" charset="-122"/>
+                <a:cs typeface="Calibri" pitchFamily="34" charset="-120"/>
+              </a:rPr>
+              <a:t>Założenia</a:t>
             </a:r>
             <a:endParaRPr lang="en-US" sz="1600" dirty="0"/>
           </a:p>
@@ -1120,14 +1093,39 @@
       </p:sp>
       <p:sp>
         <p:nvSpPr>
+          <p:cNvPr id="6" name="Shape 3"/>
+          <p:cNvSpPr/>
+          <p:nvPr/>
+        </p:nvSpPr>
+        <p:spPr>
+          <a:xfrm>
+            <a:off x="411480" y="1737360"/>
+            <a:ext cx="2697480" cy="2880360"/>
+          </a:xfrm>
+          <a:prstGeom prst="rect">
+            <a:avLst/>
+          </a:prstGeom>
+          <a:solidFill>
+            <a:srgbClr val="FFFFFF"/>
+          </a:solidFill>
+          <a:ln w="15875">
+            <a:solidFill>
+              <a:srgbClr val="174769"/>
+            </a:solidFill>
+            <a:prstDash val="solid"/>
+          </a:ln>
+        </p:spPr>
+      </p:sp>
+      <p:sp>
+        <p:nvSpPr>
           <p:cNvPr id="7" name="Text 4"/>
           <p:cNvSpPr txBox="1"/>
           <p:nvPr/>
         </p:nvSpPr>
         <p:spPr>
           <a:xfrm>
-            <a:off x="640080" y="2148840"/>
-            <a:ext cx="2327148" cy="2103120"/>
+            <a:off x="548640" y="1874520"/>
+            <a:ext cx="2441448" cy="2651760"/>
           </a:xfrm>
           <a:prstGeom prst="rect">
             <a:avLst/>
@@ -1139,67 +1137,46 @@
           <a:bodyPr wrap="square" lIns="0" tIns="0" rIns="0" bIns="0" rtlCol="0" anchor="t"/>
           <a:lstStyle/>
           <a:p>
-            <a:pPr marL="177800" indent="-177800">
+            <a:pPr marL="152400" indent="-152400">
               <a:spcAft>
-                <a:spcPts val="800"/>
+                <a:spcPts val="500"/>
               </a:spcAft>
               <a:buSzPct val="100000"/>
               <a:buChar char="•"/>
             </a:pPr>
             <a:r>
-              <a:rPr lang="en-US" sz="1300" dirty="0">
-                <a:solidFill>
-                  <a:srgbClr val="1E2A24"/>
-                </a:solidFill>
-                <a:latin typeface="Calibri" pitchFamily="34" charset="0"/>
-                <a:ea typeface="Calibri" pitchFamily="34" charset="-122"/>
-                <a:cs typeface="Calibri" pitchFamily="34" charset="-120"/>
-              </a:rPr>
-              <a:t>166 klientów na platformie (66 obecnych + 100 nowych)</a:t>
-            </a:r>
-            <a:endParaRPr lang="en-US" sz="1300" dirty="0"/>
-          </a:p>
-          <a:p>
-            <a:pPr marL="177800" indent="-177800">
+              <a:rPr lang="en-US" sz="1250" dirty="0">
+                <a:solidFill>
+                  <a:srgbClr val="30597A"/>
+                </a:solidFill>
+                <a:latin typeface="Calibri" pitchFamily="34" charset="0"/>
+                <a:ea typeface="Calibri" pitchFamily="34" charset="-122"/>
+                <a:cs typeface="Calibri" pitchFamily="34" charset="-120"/>
+              </a:rPr>
+              <a:t>Własny kanał zamówień dla sklepów i hurtu: panel sbm-partners.com, 1. zamówienie 19.03.2026</a:t>
+            </a:r>
+            <a:endParaRPr lang="en-US" sz="1250" dirty="0"/>
+          </a:p>
+          <a:p>
+            <a:pPr marL="152400" indent="-152400">
               <a:spcAft>
-                <a:spcPts val="800"/>
+                <a:spcPts val="500"/>
               </a:spcAft>
               <a:buSzPct val="100000"/>
               <a:buChar char="•"/>
             </a:pPr>
             <a:r>
-              <a:rPr lang="en-US" sz="1300" dirty="0">
-                <a:solidFill>
-                  <a:srgbClr val="1E2A24"/>
-                </a:solidFill>
-                <a:latin typeface="Calibri" pitchFamily="34" charset="0"/>
-                <a:ea typeface="Calibri" pitchFamily="34" charset="-122"/>
-                <a:cs typeface="Calibri" pitchFamily="34" charset="-120"/>
-              </a:rPr>
-              <a:t>464 tys. € sprzedaży netto</a:t>
-            </a:r>
-            <a:endParaRPr lang="en-US" sz="1300" dirty="0"/>
-          </a:p>
-          <a:p>
-            <a:pPr marL="177800" indent="-177800">
-              <a:spcAft>
-                <a:spcPts val="800"/>
-              </a:spcAft>
-              <a:buSzPct val="100000"/>
-              <a:buChar char="•"/>
-            </a:pPr>
-            <a:r>
-              <a:rPr lang="en-US" sz="1300" dirty="0">
-                <a:solidFill>
-                  <a:srgbClr val="1E2A24"/>
-                </a:solidFill>
-                <a:latin typeface="Calibri" pitchFamily="34" charset="0"/>
-                <a:ea typeface="Calibri" pitchFamily="34" charset="-122"/>
-                <a:cs typeface="Calibri" pitchFamily="34" charset="-120"/>
-              </a:rPr>
-              <a:t>928 zamówień, średnio 500 € na zamówienie</a:t>
-            </a:r>
-            <a:endParaRPr lang="en-US" sz="1300" dirty="0"/>
+              <a:rPr lang="en-US" sz="1250" dirty="0">
+                <a:solidFill>
+                  <a:srgbClr val="30597A"/>
+                </a:solidFill>
+                <a:latin typeface="Calibri" pitchFamily="34" charset="0"/>
+                <a:ea typeface="Calibri" pitchFamily="34" charset="-122"/>
+                <a:cs typeface="Calibri" pitchFamily="34" charset="-120"/>
+              </a:rPr>
+              <a:t>Business case FY26: 166 klientów, 464 tys. €, 928 zamówień, średnio 500 €</a:t>
+            </a:r>
+            <a:endParaRPr lang="en-US" sz="1250" dirty="0"/>
           </a:p>
         </p:txBody>
       </p:sp>
@@ -1211,53 +1188,26 @@
         </p:nvSpPr>
         <p:spPr>
           <a:xfrm>
-            <a:off x="3332988" y="1234440"/>
-            <a:ext cx="2647188" cy="3154680"/>
-          </a:xfrm>
-          <a:prstGeom prst="roundRect">
-            <a:avLst>
-              <a:gd name="adj" fmla="val 2763"/>
-            </a:avLst>
-          </a:prstGeom>
-          <a:solidFill>
-            <a:srgbClr val="EEF4F0"/>
+            <a:off x="3291840" y="1188720"/>
+            <a:ext cx="2697480" cy="457200"/>
+          </a:xfrm>
+          <a:prstGeom prst="rect">
+            <a:avLst/>
+          </a:prstGeom>
+          <a:solidFill>
+            <a:srgbClr val="174769"/>
           </a:solidFill>
           <a:ln w="12700">
             <a:solidFill>
-              <a:srgbClr val="EEF4F0"/>
+              <a:srgbClr val="174769"/>
             </a:solidFill>
             <a:prstDash val="solid"/>
           </a:ln>
         </p:spPr>
       </p:sp>
-      <p:sp>
-        <p:nvSpPr>
-          <p:cNvPr id="9" name="Shape 6"/>
-          <p:cNvSpPr/>
-          <p:nvPr/>
-        </p:nvSpPr>
-        <p:spPr>
-          <a:xfrm>
-            <a:off x="3561588" y="1463040"/>
-            <a:ext cx="502920" cy="502920"/>
-          </a:xfrm>
-          <a:prstGeom prst="ellipse">
-            <a:avLst/>
-          </a:prstGeom>
-          <a:solidFill>
-            <a:srgbClr val="FFFFFF"/>
-          </a:solidFill>
-          <a:ln w="19050">
-            <a:solidFill>
-              <a:srgbClr val="2E7D5B"/>
-            </a:solidFill>
-            <a:prstDash val="solid"/>
-          </a:ln>
-        </p:spPr>
-      </p:sp>
       <p:pic>
         <p:nvPicPr>
-          <p:cNvPr id="10" name="Image 1" descr="preencoded.png">    </p:cNvPr>
+          <p:cNvPr id="9" name="Image 1" descr="preencoded.png">    </p:cNvPr>
           <p:cNvPicPr>
             <a:picLocks noChangeAspect="1"/>
           </p:cNvPicPr>
@@ -1271,8 +1221,8 @@
         </p:blipFill>
         <p:spPr>
           <a:xfrm>
-            <a:off x="3685032" y="1586484"/>
-            <a:ext cx="256032" cy="256032"/>
+            <a:off x="3456432" y="1307592"/>
+            <a:ext cx="219456" cy="219456"/>
           </a:xfrm>
           <a:prstGeom prst="rect">
             <a:avLst/>
@@ -1281,14 +1231,14 @@
       </p:pic>
       <p:sp>
         <p:nvSpPr>
-          <p:cNvPr id="11" name="Text 7"/>
-          <p:cNvSpPr txBox="1"/>
-          <p:nvPr/>
-        </p:nvSpPr>
-        <p:spPr>
-          <a:xfrm>
-            <a:off x="4201668" y="1463040"/>
-            <a:ext cx="1641348" cy="502920"/>
+          <p:cNvPr id="10" name="Text 6"/>
+          <p:cNvSpPr txBox="1"/>
+          <p:nvPr/>
+        </p:nvSpPr>
+        <p:spPr>
+          <a:xfrm>
+            <a:off x="3767328" y="1188720"/>
+            <a:ext cx="2148840" cy="457200"/>
           </a:xfrm>
           <a:prstGeom prst="rect">
             <a:avLst/>
@@ -1306,7 +1256,7 @@
             <a:r>
               <a:rPr lang="en-US" sz="1600" b="1" dirty="0">
                 <a:solidFill>
-                  <a:srgbClr val="1F4E3D"/>
+                  <a:srgbClr val="FFFFFF"/>
                 </a:solidFill>
                 <a:latin typeface="Calibri" pitchFamily="34" charset="0"/>
                 <a:ea typeface="Calibri" pitchFamily="34" charset="-122"/>
@@ -1320,14 +1270,39 @@
       </p:sp>
       <p:sp>
         <p:nvSpPr>
+          <p:cNvPr id="11" name="Shape 7"/>
+          <p:cNvSpPr/>
+          <p:nvPr/>
+        </p:nvSpPr>
+        <p:spPr>
+          <a:xfrm>
+            <a:off x="3291840" y="1737360"/>
+            <a:ext cx="2697480" cy="2880360"/>
+          </a:xfrm>
+          <a:prstGeom prst="rect">
+            <a:avLst/>
+          </a:prstGeom>
+          <a:solidFill>
+            <a:srgbClr val="FFFFFF"/>
+          </a:solidFill>
+          <a:ln w="15875">
+            <a:solidFill>
+              <a:srgbClr val="174769"/>
+            </a:solidFill>
+            <a:prstDash val="solid"/>
+          </a:ln>
+        </p:spPr>
+      </p:sp>
+      <p:sp>
+        <p:nvSpPr>
           <p:cNvPr id="12" name="Text 8"/>
           <p:cNvSpPr txBox="1"/>
           <p:nvPr/>
         </p:nvSpPr>
         <p:spPr>
           <a:xfrm>
-            <a:off x="3515868" y="2148840"/>
-            <a:ext cx="2327148" cy="2103120"/>
+            <a:off x="3429000" y="1874520"/>
+            <a:ext cx="2441448" cy="2651760"/>
           </a:xfrm>
           <a:prstGeom prst="rect">
             <a:avLst/>
@@ -1339,67 +1314,67 @@
           <a:bodyPr wrap="square" lIns="0" tIns="0" rIns="0" bIns="0" rtlCol="0" anchor="t"/>
           <a:lstStyle/>
           <a:p>
-            <a:pPr marL="177800" indent="-177800">
+            <a:pPr marL="152400" indent="-152400">
               <a:spcAft>
-                <a:spcPts val="800"/>
+                <a:spcPts val="500"/>
               </a:spcAft>
               <a:buSzPct val="100000"/>
               <a:buChar char="•"/>
             </a:pPr>
             <a:r>
-              <a:rPr lang="en-US" sz="1300" dirty="0">
-                <a:solidFill>
-                  <a:srgbClr val="1E2A24"/>
-                </a:solidFill>
-                <a:latin typeface="Calibri" pitchFamily="34" charset="0"/>
-                <a:ea typeface="Calibri" pitchFamily="34" charset="-122"/>
-                <a:cs typeface="Calibri" pitchFamily="34" charset="-120"/>
-              </a:rPr>
-              <a:t>Cała baza klientów przeniesiona na platformę</a:t>
-            </a:r>
-            <a:endParaRPr lang="en-US" sz="1300" dirty="0"/>
-          </a:p>
-          <a:p>
-            <a:pPr marL="177800" indent="-177800">
+              <a:rPr lang="en-US" sz="1250" dirty="0">
+                <a:solidFill>
+                  <a:srgbClr val="30597A"/>
+                </a:solidFill>
+                <a:latin typeface="Calibri" pitchFamily="34" charset="0"/>
+                <a:ea typeface="Calibri" pitchFamily="34" charset="-122"/>
+                <a:cs typeface="Calibri" pitchFamily="34" charset="-120"/>
+              </a:rPr>
+              <a:t>Cała baza na panelu: rejestracja, konta, grupy cenowe</a:t>
+            </a:r>
+            <a:endParaRPr lang="en-US" sz="1250" dirty="0"/>
+          </a:p>
+          <a:p>
+            <a:pPr marL="152400" indent="-152400">
               <a:spcAft>
-                <a:spcPts val="800"/>
+                <a:spcPts val="500"/>
               </a:spcAft>
               <a:buSzPct val="100000"/>
               <a:buChar char="•"/>
             </a:pPr>
             <a:r>
-              <a:rPr lang="en-US" sz="1300" dirty="0">
-                <a:solidFill>
-                  <a:srgbClr val="1E2A24"/>
-                </a:solidFill>
-                <a:latin typeface="Calibri" pitchFamily="34" charset="0"/>
-                <a:ea typeface="Calibri" pitchFamily="34" charset="-122"/>
-                <a:cs typeface="Calibri" pitchFamily="34" charset="-120"/>
-              </a:rPr>
-              <a:t>Onboarding przez przedstawicieli: cel 5 nowych kont tygodniowo na osobę</a:t>
-            </a:r>
-            <a:endParaRPr lang="en-US" sz="1300" dirty="0"/>
-          </a:p>
-          <a:p>
-            <a:pPr marL="177800" indent="-177800">
+              <a:rPr lang="en-US" sz="1250" dirty="0">
+                <a:solidFill>
+                  <a:srgbClr val="30597A"/>
+                </a:solidFill>
+                <a:latin typeface="Calibri" pitchFamily="34" charset="0"/>
+                <a:ea typeface="Calibri" pitchFamily="34" charset="-122"/>
+                <a:cs typeface="Calibri" pitchFamily="34" charset="-120"/>
+              </a:rPr>
+              <a:t>Ceny netto z rabatem klienta; płatność 90 dni lub 7 dni z 2,5% rabatu</a:t>
+            </a:r>
+            <a:endParaRPr lang="en-US" sz="1250" dirty="0"/>
+          </a:p>
+          <a:p>
+            <a:pPr marL="152400" indent="-152400">
               <a:spcAft>
-                <a:spcPts val="800"/>
+                <a:spcPts val="500"/>
               </a:spcAft>
               <a:buSzPct val="100000"/>
               <a:buChar char="•"/>
             </a:pPr>
             <a:r>
-              <a:rPr lang="en-US" sz="1300" dirty="0">
-                <a:solidFill>
-                  <a:srgbClr val="1E2A24"/>
-                </a:solidFill>
-                <a:latin typeface="Calibri" pitchFamily="34" charset="0"/>
-                <a:ea typeface="Calibri" pitchFamily="34" charset="-122"/>
-                <a:cs typeface="Calibri" pitchFamily="34" charset="-120"/>
-              </a:rPr>
-              <a:t>Cotygodniowy raport KPI (Power BI + tracker klientów)</a:t>
-            </a:r>
-            <a:endParaRPr lang="en-US" sz="1300" dirty="0"/>
+              <a:rPr lang="en-US" sz="1250" dirty="0">
+                <a:solidFill>
+                  <a:srgbClr val="30597A"/>
+                </a:solidFill>
+                <a:latin typeface="Calibri" pitchFamily="34" charset="0"/>
+                <a:ea typeface="Calibri" pitchFamily="34" charset="-122"/>
+                <a:cs typeface="Calibri" pitchFamily="34" charset="-120"/>
+              </a:rPr>
+              <a:t>Od 12.06 klienci przypisani do KAM + cotygodniowy raport KPI</a:t>
+            </a:r>
+            <a:endParaRPr lang="en-US" sz="1250" dirty="0"/>
           </a:p>
         </p:txBody>
       </p:sp>
@@ -1411,53 +1386,26 @@
         </p:nvSpPr>
         <p:spPr>
           <a:xfrm>
-            <a:off x="6208776" y="1234440"/>
-            <a:ext cx="2647188" cy="3154680"/>
-          </a:xfrm>
-          <a:prstGeom prst="roundRect">
-            <a:avLst>
-              <a:gd name="adj" fmla="val 2763"/>
-            </a:avLst>
-          </a:prstGeom>
-          <a:solidFill>
-            <a:srgbClr val="EEF4F0"/>
+            <a:off x="6172200" y="1188720"/>
+            <a:ext cx="2697480" cy="457200"/>
+          </a:xfrm>
+          <a:prstGeom prst="rect">
+            <a:avLst/>
+          </a:prstGeom>
+          <a:solidFill>
+            <a:srgbClr val="174769"/>
           </a:solidFill>
           <a:ln w="12700">
             <a:solidFill>
-              <a:srgbClr val="EEF4F0"/>
+              <a:srgbClr val="174769"/>
             </a:solidFill>
             <a:prstDash val="solid"/>
           </a:ln>
         </p:spPr>
       </p:sp>
-      <p:sp>
-        <p:nvSpPr>
-          <p:cNvPr id="14" name="Shape 10"/>
-          <p:cNvSpPr/>
-          <p:nvPr/>
-        </p:nvSpPr>
-        <p:spPr>
-          <a:xfrm>
-            <a:off x="6437376" y="1463040"/>
-            <a:ext cx="502920" cy="502920"/>
-          </a:xfrm>
-          <a:prstGeom prst="ellipse">
-            <a:avLst/>
-          </a:prstGeom>
-          <a:solidFill>
-            <a:srgbClr val="FFFFFF"/>
-          </a:solidFill>
-          <a:ln w="19050">
-            <a:solidFill>
-              <a:srgbClr val="2E7D5B"/>
-            </a:solidFill>
-            <a:prstDash val="solid"/>
-          </a:ln>
-        </p:spPr>
-      </p:sp>
       <p:pic>
         <p:nvPicPr>
-          <p:cNvPr id="15" name="Image 2" descr="preencoded.png">    </p:cNvPr>
+          <p:cNvPr id="14" name="Image 2" descr="preencoded.png">    </p:cNvPr>
           <p:cNvPicPr>
             <a:picLocks noChangeAspect="1"/>
           </p:cNvPicPr>
@@ -1471,8 +1419,8 @@
         </p:blipFill>
         <p:spPr>
           <a:xfrm>
-            <a:off x="6560820" y="1586484"/>
-            <a:ext cx="256032" cy="256032"/>
+            <a:off x="6336792" y="1307592"/>
+            <a:ext cx="219456" cy="219456"/>
           </a:xfrm>
           <a:prstGeom prst="rect">
             <a:avLst/>
@@ -1481,14 +1429,14 @@
       </p:pic>
       <p:sp>
         <p:nvSpPr>
-          <p:cNvPr id="16" name="Text 11"/>
-          <p:cNvSpPr txBox="1"/>
-          <p:nvPr/>
-        </p:nvSpPr>
-        <p:spPr>
-          <a:xfrm>
-            <a:off x="7077456" y="1463040"/>
-            <a:ext cx="1641348" cy="502920"/>
+          <p:cNvPr id="15" name="Text 10"/>
+          <p:cNvSpPr txBox="1"/>
+          <p:nvPr/>
+        </p:nvSpPr>
+        <p:spPr>
+          <a:xfrm>
+            <a:off x="6647688" y="1188720"/>
+            <a:ext cx="2148840" cy="457200"/>
           </a:xfrm>
           <a:prstGeom prst="rect">
             <a:avLst/>
@@ -1506,7 +1454,7 @@
             <a:r>
               <a:rPr lang="en-US" sz="1600" b="1" dirty="0">
                 <a:solidFill>
-                  <a:srgbClr val="1F4E3D"/>
+                  <a:srgbClr val="FFFFFF"/>
                 </a:solidFill>
                 <a:latin typeface="Calibri" pitchFamily="34" charset="0"/>
                 <a:ea typeface="Calibri" pitchFamily="34" charset="-122"/>
@@ -1520,14 +1468,39 @@
       </p:sp>
       <p:sp>
         <p:nvSpPr>
+          <p:cNvPr id="16" name="Shape 11"/>
+          <p:cNvSpPr/>
+          <p:nvPr/>
+        </p:nvSpPr>
+        <p:spPr>
+          <a:xfrm>
+            <a:off x="6172200" y="1737360"/>
+            <a:ext cx="2697480" cy="2880360"/>
+          </a:xfrm>
+          <a:prstGeom prst="rect">
+            <a:avLst/>
+          </a:prstGeom>
+          <a:solidFill>
+            <a:srgbClr val="FFFFFF"/>
+          </a:solidFill>
+          <a:ln w="15875">
+            <a:solidFill>
+              <a:srgbClr val="174769"/>
+            </a:solidFill>
+            <a:prstDash val="solid"/>
+          </a:ln>
+        </p:spPr>
+      </p:sp>
+      <p:sp>
+        <p:nvSpPr>
           <p:cNvPr id="17" name="Text 12"/>
           <p:cNvSpPr txBox="1"/>
           <p:nvPr/>
         </p:nvSpPr>
         <p:spPr>
           <a:xfrm>
-            <a:off x="6391656" y="2148840"/>
-            <a:ext cx="2327148" cy="2103120"/>
+            <a:off x="6309360" y="1874520"/>
+            <a:ext cx="2441448" cy="2651760"/>
           </a:xfrm>
           <a:prstGeom prst="rect">
             <a:avLst/>
@@ -1539,67 +1512,88 @@
           <a:bodyPr wrap="square" lIns="0" tIns="0" rIns="0" bIns="0" rtlCol="0" anchor="t"/>
           <a:lstStyle/>
           <a:p>
-            <a:pPr marL="177800" indent="-177800">
+            <a:pPr marL="152400" indent="-152400">
               <a:spcAft>
-                <a:spcPts val="800"/>
+                <a:spcPts val="500"/>
               </a:spcAft>
               <a:buSzPct val="100000"/>
               <a:buChar char="•"/>
             </a:pPr>
             <a:r>
-              <a:rPr lang="en-US" sz="1300" dirty="0">
-                <a:solidFill>
-                  <a:srgbClr val="1E2A24"/>
-                </a:solidFill>
-                <a:latin typeface="Calibri" pitchFamily="34" charset="0"/>
-                <a:ea typeface="Calibri" pitchFamily="34" charset="-122"/>
-                <a:cs typeface="Calibri" pitchFamily="34" charset="-120"/>
-              </a:rPr>
-              <a:t>174 kont na platformie = 105% założonej bazy</a:t>
-            </a:r>
-            <a:endParaRPr lang="en-US" sz="1300" dirty="0"/>
-          </a:p>
-          <a:p>
-            <a:pPr marL="177800" indent="-177800">
+              <a:rPr lang="en-US" sz="1250" dirty="0">
+                <a:solidFill>
+                  <a:srgbClr val="30597A"/>
+                </a:solidFill>
+                <a:latin typeface="Calibri" pitchFamily="34" charset="0"/>
+                <a:ea typeface="Calibri" pitchFamily="34" charset="-122"/>
+                <a:cs typeface="Calibri" pitchFamily="34" charset="-120"/>
+              </a:rPr>
+              <a:t>174 kont (105% bazy), 127 z zamówieniem</a:t>
+            </a:r>
+            <a:endParaRPr lang="en-US" sz="1250" dirty="0"/>
+          </a:p>
+          <a:p>
+            <a:pPr marL="152400" indent="-152400">
               <a:spcAft>
-                <a:spcPts val="800"/>
+                <a:spcPts val="500"/>
               </a:spcAft>
               <a:buSzPct val="100000"/>
               <a:buChar char="•"/>
             </a:pPr>
             <a:r>
-              <a:rPr lang="en-US" sz="1300" dirty="0">
-                <a:solidFill>
-                  <a:srgbClr val="1E2A24"/>
-                </a:solidFill>
-                <a:latin typeface="Calibri" pitchFamily="34" charset="0"/>
-                <a:ea typeface="Calibri" pitchFamily="34" charset="-122"/>
-                <a:cs typeface="Calibri" pitchFamily="34" charset="-120"/>
-              </a:rPr>
-              <a:t>396,8 tys. € sprzedaży = 86% budżetu, 105% planu do dziś</a:t>
-            </a:r>
-            <a:endParaRPr lang="en-US" sz="1300" dirty="0"/>
-          </a:p>
-          <a:p>
-            <a:pPr marL="177800" indent="-177800">
+              <a:rPr lang="en-US" sz="1250" dirty="0">
+                <a:solidFill>
+                  <a:srgbClr val="30597A"/>
+                </a:solidFill>
+                <a:latin typeface="Calibri" pitchFamily="34" charset="0"/>
+                <a:ea typeface="Calibri" pitchFamily="34" charset="-122"/>
+                <a:cs typeface="Calibri" pitchFamily="34" charset="-120"/>
+              </a:rPr>
+              <a:t>396,8 tys. € = 86% budżetu, 105% planu do dziś</a:t>
+            </a:r>
+            <a:endParaRPr lang="en-US" sz="1250" dirty="0"/>
+          </a:p>
+          <a:p>
+            <a:pPr marL="152400" indent="-152400">
               <a:spcAft>
-                <a:spcPts val="800"/>
+                <a:spcPts val="500"/>
               </a:spcAft>
               <a:buSzPct val="100000"/>
               <a:buChar char="•"/>
             </a:pPr>
             <a:r>
-              <a:rPr lang="en-US" sz="1300" dirty="0">
-                <a:solidFill>
-                  <a:srgbClr val="1E2A24"/>
-                </a:solidFill>
-                <a:latin typeface="Calibri" pitchFamily="34" charset="0"/>
-                <a:ea typeface="Calibri" pitchFamily="34" charset="-122"/>
-                <a:cs typeface="Calibri" pitchFamily="34" charset="-120"/>
-              </a:rPr>
-              <a:t>Średnie zamówienie 1 288 € (2,6× plan)</a:t>
-            </a:r>
-            <a:endParaRPr lang="en-US" sz="1300" dirty="0"/>
+              <a:rPr lang="en-US" sz="1250" dirty="0">
+                <a:solidFill>
+                  <a:srgbClr val="30597A"/>
+                </a:solidFill>
+                <a:latin typeface="Calibri" pitchFamily="34" charset="0"/>
+                <a:ea typeface="Calibri" pitchFamily="34" charset="-122"/>
+                <a:cs typeface="Calibri" pitchFamily="34" charset="-120"/>
+              </a:rPr>
+              <a:t>59% klientów wraca z 2. zamówieniem w ciągu 60 dni</a:t>
+            </a:r>
+            <a:endParaRPr lang="en-US" sz="1250" dirty="0"/>
+          </a:p>
+          <a:p>
+            <a:pPr marL="152400" indent="-152400">
+              <a:spcAft>
+                <a:spcPts val="500"/>
+              </a:spcAft>
+              <a:buSzPct val="100000"/>
+              <a:buChar char="•"/>
+            </a:pPr>
+            <a:r>
+              <a:rPr lang="en-US" sz="1250" dirty="0">
+                <a:solidFill>
+                  <a:srgbClr val="30597A"/>
+                </a:solidFill>
+                <a:latin typeface="Calibri" pitchFamily="34" charset="0"/>
+                <a:ea typeface="Calibri" pitchFamily="34" charset="-122"/>
+                <a:cs typeface="Calibri" pitchFamily="34" charset="-120"/>
+              </a:rPr>
+              <a:t>Część klientów zamawia sama, bez telefonu do PH</a:t>
+            </a:r>
+            <a:endParaRPr lang="en-US" sz="1250" dirty="0"/>
           </a:p>
         </p:txBody>
       </p:sp>
@@ -1611,53 +1605,26 @@
         </p:nvSpPr>
         <p:spPr>
           <a:xfrm>
-            <a:off x="9084564" y="1234440"/>
-            <a:ext cx="2647188" cy="3154680"/>
-          </a:xfrm>
-          <a:prstGeom prst="roundRect">
-            <a:avLst>
-              <a:gd name="adj" fmla="val 2763"/>
-            </a:avLst>
-          </a:prstGeom>
-          <a:solidFill>
-            <a:srgbClr val="EEF4F0"/>
+            <a:off x="9052560" y="1188720"/>
+            <a:ext cx="2697480" cy="457200"/>
+          </a:xfrm>
+          <a:prstGeom prst="rect">
+            <a:avLst/>
+          </a:prstGeom>
+          <a:solidFill>
+            <a:srgbClr val="174769"/>
           </a:solidFill>
           <a:ln w="12700">
             <a:solidFill>
-              <a:srgbClr val="EEF4F0"/>
+              <a:srgbClr val="174769"/>
             </a:solidFill>
             <a:prstDash val="solid"/>
           </a:ln>
         </p:spPr>
       </p:sp>
-      <p:sp>
-        <p:nvSpPr>
-          <p:cNvPr id="19" name="Shape 14"/>
-          <p:cNvSpPr/>
-          <p:nvPr/>
-        </p:nvSpPr>
-        <p:spPr>
-          <a:xfrm>
-            <a:off x="9313164" y="1463040"/>
-            <a:ext cx="502920" cy="502920"/>
-          </a:xfrm>
-          <a:prstGeom prst="ellipse">
-            <a:avLst/>
-          </a:prstGeom>
-          <a:solidFill>
-            <a:srgbClr val="FFFFFF"/>
-          </a:solidFill>
-          <a:ln w="19050">
-            <a:solidFill>
-              <a:srgbClr val="C0392B"/>
-            </a:solidFill>
-            <a:prstDash val="solid"/>
-          </a:ln>
-        </p:spPr>
-      </p:sp>
       <p:pic>
         <p:nvPicPr>
-          <p:cNvPr id="20" name="Image 3" descr="preencoded.png">    </p:cNvPr>
+          <p:cNvPr id="19" name="Image 3" descr="preencoded.png">    </p:cNvPr>
           <p:cNvPicPr>
             <a:picLocks noChangeAspect="1"/>
           </p:cNvPicPr>
@@ -1671,8 +1638,8 @@
         </p:blipFill>
         <p:spPr>
           <a:xfrm>
-            <a:off x="9436608" y="1586484"/>
-            <a:ext cx="256032" cy="256032"/>
+            <a:off x="9217152" y="1307592"/>
+            <a:ext cx="219456" cy="219456"/>
           </a:xfrm>
           <a:prstGeom prst="rect">
             <a:avLst/>
@@ -1681,14 +1648,14 @@
       </p:pic>
       <p:sp>
         <p:nvSpPr>
-          <p:cNvPr id="21" name="Text 15"/>
-          <p:cNvSpPr txBox="1"/>
-          <p:nvPr/>
-        </p:nvSpPr>
-        <p:spPr>
-          <a:xfrm>
-            <a:off x="9953244" y="1463040"/>
-            <a:ext cx="1641348" cy="502920"/>
+          <p:cNvPr id="20" name="Text 14"/>
+          <p:cNvSpPr txBox="1"/>
+          <p:nvPr/>
+        </p:nvSpPr>
+        <p:spPr>
+          <a:xfrm>
+            <a:off x="9528048" y="1188720"/>
+            <a:ext cx="2148840" cy="457200"/>
           </a:xfrm>
           <a:prstGeom prst="rect">
             <a:avLst/>
@@ -1706,7 +1673,7 @@
             <a:r>
               <a:rPr lang="en-US" sz="1600" b="1" dirty="0">
                 <a:solidFill>
-                  <a:srgbClr val="C0392B"/>
+                  <a:srgbClr val="FFFFFF"/>
                 </a:solidFill>
                 <a:latin typeface="Calibri" pitchFamily="34" charset="0"/>
                 <a:ea typeface="Calibri" pitchFamily="34" charset="-122"/>
@@ -1720,14 +1687,39 @@
       </p:sp>
       <p:sp>
         <p:nvSpPr>
+          <p:cNvPr id="21" name="Shape 15"/>
+          <p:cNvSpPr/>
+          <p:nvPr/>
+        </p:nvSpPr>
+        <p:spPr>
+          <a:xfrm>
+            <a:off x="9052560" y="1737360"/>
+            <a:ext cx="2697480" cy="2880360"/>
+          </a:xfrm>
+          <a:prstGeom prst="rect">
+            <a:avLst/>
+          </a:prstGeom>
+          <a:solidFill>
+            <a:srgbClr val="FFFFFF"/>
+          </a:solidFill>
+          <a:ln w="15875">
+            <a:solidFill>
+              <a:srgbClr val="174769"/>
+            </a:solidFill>
+            <a:prstDash val="solid"/>
+          </a:ln>
+        </p:spPr>
+      </p:sp>
+      <p:sp>
+        <p:nvSpPr>
           <p:cNvPr id="22" name="Text 16"/>
           <p:cNvSpPr txBox="1"/>
           <p:nvPr/>
         </p:nvSpPr>
         <p:spPr>
           <a:xfrm>
-            <a:off x="9267444" y="2148840"/>
-            <a:ext cx="2327148" cy="2103120"/>
+            <a:off x="9189720" y="1874520"/>
+            <a:ext cx="2441448" cy="2651760"/>
           </a:xfrm>
           <a:prstGeom prst="rect">
             <a:avLst/>
@@ -1739,17 +1731,17 @@
           <a:bodyPr wrap="square" lIns="0" tIns="0" rIns="0" bIns="0" rtlCol="0" anchor="t"/>
           <a:lstStyle/>
           <a:p>
-            <a:pPr marL="177800" indent="-177800">
+            <a:pPr marL="152400" indent="-152400">
               <a:spcAft>
-                <a:spcPts val="800"/>
+                <a:spcPts val="500"/>
               </a:spcAft>
               <a:buSzPct val="100000"/>
               <a:buChar char="•"/>
             </a:pPr>
             <a:r>
-              <a:rPr lang="en-US" sz="1300" dirty="0">
-                <a:solidFill>
-                  <a:srgbClr val="1E2A24"/>
+              <a:rPr lang="en-US" sz="1250" dirty="0">
+                <a:solidFill>
+                  <a:srgbClr val="30597A"/>
                 </a:solidFill>
                 <a:latin typeface="Calibri" pitchFamily="34" charset="0"/>
                 <a:ea typeface="Calibri" pitchFamily="34" charset="-122"/>
@@ -1757,49 +1749,70 @@
               </a:rPr>
               <a:t>308 zamówień = 33% celu: rzadkie, duże zamówienia „na stock”</a:t>
             </a:r>
-            <a:endParaRPr lang="en-US" sz="1300" dirty="0"/>
-          </a:p>
-          <a:p>
-            <a:pPr marL="177800" indent="-177800">
+            <a:endParaRPr lang="en-US" sz="1250" dirty="0"/>
+          </a:p>
+          <a:p>
+            <a:pPr marL="152400" indent="-152400">
               <a:spcAft>
-                <a:spcPts val="800"/>
+                <a:spcPts val="500"/>
               </a:spcAft>
               <a:buSzPct val="100000"/>
               <a:buChar char="•"/>
             </a:pPr>
             <a:r>
-              <a:rPr lang="en-US" sz="1300" dirty="0">
-                <a:solidFill>
-                  <a:srgbClr val="1E2A24"/>
-                </a:solidFill>
-                <a:latin typeface="Calibri" pitchFamily="34" charset="0"/>
-                <a:ea typeface="Calibri" pitchFamily="34" charset="-122"/>
-                <a:cs typeface="Calibri" pitchFamily="34" charset="-120"/>
-              </a:rPr>
-              <a:t>47 kont bez żadnego zamówienia</a:t>
-            </a:r>
-            <a:endParaRPr lang="en-US" sz="1300" dirty="0"/>
-          </a:p>
-          <a:p>
-            <a:pPr marL="177800" indent="-177800">
+              <a:rPr lang="en-US" sz="1250" dirty="0">
+                <a:solidFill>
+                  <a:srgbClr val="30597A"/>
+                </a:solidFill>
+                <a:latin typeface="Calibri" pitchFamily="34" charset="0"/>
+                <a:ea typeface="Calibri" pitchFamily="34" charset="-122"/>
+                <a:cs typeface="Calibri" pitchFamily="34" charset="-120"/>
+              </a:rPr>
+              <a:t>Brak kampanii B2B i kontaktu w sezonie (newsletter, SMS)</a:t>
+            </a:r>
+            <a:endParaRPr lang="en-US" sz="1250" dirty="0"/>
+          </a:p>
+          <a:p>
+            <a:pPr marL="152400" indent="-152400">
               <a:spcAft>
-                <a:spcPts val="800"/>
+                <a:spcPts val="500"/>
               </a:spcAft>
               <a:buSzPct val="100000"/>
               <a:buChar char="•"/>
             </a:pPr>
             <a:r>
-              <a:rPr lang="en-US" sz="1300" dirty="0">
-                <a:solidFill>
-                  <a:srgbClr val="1E2A24"/>
-                </a:solidFill>
-                <a:latin typeface="Calibri" pitchFamily="34" charset="0"/>
-                <a:ea typeface="Calibri" pitchFamily="34" charset="-122"/>
-                <a:cs typeface="Calibri" pitchFamily="34" charset="-120"/>
-              </a:rPr>
-              <a:t>Brak komunikacji po rejestracji i działań retencyjnych</a:t>
-            </a:r>
-            <a:endParaRPr lang="en-US" sz="1300" dirty="0"/>
+              <a:rPr lang="en-US" sz="1250" dirty="0">
+                <a:solidFill>
+                  <a:srgbClr val="30597A"/>
+                </a:solidFill>
+                <a:latin typeface="Calibri" pitchFamily="34" charset="0"/>
+                <a:ea typeface="Calibri" pitchFamily="34" charset="-122"/>
+                <a:cs typeface="Calibri" pitchFamily="34" charset="-120"/>
+              </a:rPr>
+              <a:t>Korekty cen ręcznie w Sage: klient widzi inne kwoty niż na fakturze, brak śledzenia przesyłek</a:t>
+            </a:r>
+            <a:endParaRPr lang="en-US" sz="1250" dirty="0"/>
+          </a:p>
+          <a:p>
+            <a:pPr marL="152400" indent="-152400">
+              <a:spcAft>
+                <a:spcPts val="500"/>
+              </a:spcAft>
+              <a:buSzPct val="100000"/>
+              <a:buChar char="•"/>
+            </a:pPr>
+            <a:r>
+              <a:rPr lang="en-US" sz="1250" dirty="0">
+                <a:solidFill>
+                  <a:srgbClr val="30597A"/>
+                </a:solidFill>
+                <a:latin typeface="Calibri" pitchFamily="34" charset="0"/>
+                <a:ea typeface="Calibri" pitchFamily="34" charset="-122"/>
+                <a:cs typeface="Calibri" pitchFamily="34" charset="-120"/>
+              </a:rPr>
+              <a:t>Brak programu lojalnościowego, niewygodny panel</a:t>
+            </a:r>
+            <a:endParaRPr lang="en-US" sz="1250" dirty="0"/>
           </a:p>
         </p:txBody>
       </p:sp>
@@ -1811,20 +1824,18 @@
         </p:nvSpPr>
         <p:spPr>
           <a:xfrm>
-            <a:off x="457200" y="4617720"/>
-            <a:ext cx="11274552" cy="1828800"/>
-          </a:xfrm>
-          <a:prstGeom prst="roundRect">
-            <a:avLst>
-              <a:gd name="adj" fmla="val 4000"/>
-            </a:avLst>
-          </a:prstGeom>
-          <a:solidFill>
-            <a:srgbClr val="1F4E3D"/>
+            <a:off x="411480" y="4800600"/>
+            <a:ext cx="11338560" cy="1691640"/>
+          </a:xfrm>
+          <a:prstGeom prst="rect">
+            <a:avLst/>
+          </a:prstGeom>
+          <a:solidFill>
+            <a:srgbClr val="174769"/>
           </a:solidFill>
           <a:ln w="12700">
             <a:solidFill>
-              <a:srgbClr val="1F4E3D"/>
+              <a:srgbClr val="174769"/>
             </a:solidFill>
             <a:prstDash val="solid"/>
           </a:ln>
@@ -1838,8 +1849,8 @@
         </p:nvSpPr>
         <p:spPr>
           <a:xfrm>
-            <a:off x="731520" y="4782312"/>
-            <a:ext cx="5486400" cy="365760"/>
+            <a:off x="685800" y="4937760"/>
+            <a:ext cx="5486400" cy="320040"/>
           </a:xfrm>
           <a:prstGeom prst="rect">
             <a:avLst/>
@@ -1855,17 +1866,17 @@
               <a:buNone/>
             </a:pPr>
             <a:r>
-              <a:rPr lang="en-US" sz="1800" b="1" dirty="0">
-                <a:solidFill>
-                  <a:srgbClr val="FFFFFF"/>
-                </a:solidFill>
-                <a:latin typeface="Cambria" pitchFamily="34" charset="0"/>
-                <a:ea typeface="Cambria" pitchFamily="34" charset="-122"/>
-                <a:cs typeface="Cambria" pitchFamily="34" charset="-120"/>
-              </a:rPr>
-              <a:t>Learningi na FY27</a:t>
-            </a:r>
-            <a:endParaRPr lang="en-US" sz="1800" dirty="0"/>
+              <a:rPr lang="en-US" sz="1600" b="1" dirty="0">
+                <a:solidFill>
+                  <a:srgbClr val="F8AF2D"/>
+                </a:solidFill>
+                <a:latin typeface="Calibri" pitchFamily="34" charset="0"/>
+                <a:ea typeface="Calibri" pitchFamily="34" charset="-122"/>
+                <a:cs typeface="Calibri" pitchFamily="34" charset="-120"/>
+              </a:rPr>
+              <a:t>LEARNINGI NA FY27</a:t>
+            </a:r>
+            <a:endParaRPr lang="en-US" sz="1600" dirty="0"/>
           </a:p>
         </p:txBody>
       </p:sp>
@@ -1877,18 +1888,18 @@
         </p:nvSpPr>
         <p:spPr>
           <a:xfrm>
-            <a:off x="731520" y="5330952"/>
-            <a:ext cx="420624" cy="420624"/>
+            <a:off x="685800" y="5422392"/>
+            <a:ext cx="384048" cy="384048"/>
           </a:xfrm>
           <a:prstGeom prst="ellipse">
             <a:avLst/>
           </a:prstGeom>
           <a:solidFill>
-            <a:srgbClr val="E0A100"/>
+            <a:srgbClr val="F8AF2D"/>
           </a:solidFill>
           <a:ln w="12700">
             <a:solidFill>
-              <a:srgbClr val="E0A100"/>
+              <a:srgbClr val="F8AF2D"/>
             </a:solidFill>
             <a:prstDash val="solid"/>
           </a:ln>
@@ -1902,8 +1913,8 @@
         </p:nvSpPr>
         <p:spPr>
           <a:xfrm>
-            <a:off x="731520" y="5330952"/>
-            <a:ext cx="420624" cy="420624"/>
+            <a:off x="685800" y="5422392"/>
+            <a:ext cx="384048" cy="384048"/>
           </a:xfrm>
           <a:prstGeom prst="rect">
             <a:avLst/>
@@ -1919,9 +1930,9 @@
               <a:buNone/>
             </a:pPr>
             <a:r>
-              <a:rPr lang="en-US" sz="1600" b="1" dirty="0">
-                <a:solidFill>
-                  <a:srgbClr val="1F4E3D"/>
+              <a:rPr lang="en-US" sz="1500" b="1" dirty="0">
+                <a:solidFill>
+                  <a:srgbClr val="174769"/>
                 </a:solidFill>
                 <a:latin typeface="Calibri" pitchFamily="34" charset="0"/>
                 <a:ea typeface="Calibri" pitchFamily="34" charset="-122"/>
@@ -1929,7 +1940,7 @@
               </a:rPr>
               <a:t>1</a:t>
             </a:r>
-            <a:endParaRPr lang="en-US" sz="1600" dirty="0"/>
+            <a:endParaRPr lang="en-US" sz="1500" dirty="0"/>
           </a:p>
         </p:txBody>
       </p:sp>
@@ -1941,8 +1952,8 @@
         </p:nvSpPr>
         <p:spPr>
           <a:xfrm>
-            <a:off x="1261872" y="5221224"/>
-            <a:ext cx="2039112" cy="1005840"/>
+            <a:off x="1161288" y="5330952"/>
+            <a:ext cx="2121408" cy="1051560"/>
           </a:xfrm>
           <a:prstGeom prst="rect">
             <a:avLst/>
@@ -1958,7 +1969,7 @@
               <a:buNone/>
             </a:pPr>
             <a:r>
-              <a:rPr lang="en-US" sz="1300" dirty="0">
+              <a:rPr lang="en-US" sz="1250" dirty="0">
                 <a:solidFill>
                   <a:srgbClr val="FFFFFF"/>
                 </a:solidFill>
@@ -1966,9 +1977,9 @@
                 <a:ea typeface="Calibri" pitchFamily="34" charset="-122"/>
                 <a:cs typeface="Calibri" pitchFamily="34" charset="-120"/>
               </a:rPr>
-              <a:t>Rejestracja to start, nie meta: liczymy konta, które zamawiają</a:t>
-            </a:r>
-            <a:endParaRPr lang="en-US" sz="1300" dirty="0"/>
+              <a:t>Kampania B2B i budżet mediowy, nie tylko pozyskanie przez PH</a:t>
+            </a:r>
+            <a:endParaRPr lang="en-US" sz="1250" dirty="0"/>
           </a:p>
         </p:txBody>
       </p:sp>
@@ -1980,18 +1991,18 @@
         </p:nvSpPr>
         <p:spPr>
           <a:xfrm>
-            <a:off x="3502152" y="5330952"/>
-            <a:ext cx="420624" cy="420624"/>
+            <a:off x="3447288" y="5422392"/>
+            <a:ext cx="384048" cy="384048"/>
           </a:xfrm>
           <a:prstGeom prst="ellipse">
             <a:avLst/>
           </a:prstGeom>
           <a:solidFill>
-            <a:srgbClr val="E0A100"/>
+            <a:srgbClr val="F8AF2D"/>
           </a:solidFill>
           <a:ln w="12700">
             <a:solidFill>
-              <a:srgbClr val="E0A100"/>
+              <a:srgbClr val="F8AF2D"/>
             </a:solidFill>
             <a:prstDash val="solid"/>
           </a:ln>
@@ -2005,8 +2016,8 @@
         </p:nvSpPr>
         <p:spPr>
           <a:xfrm>
-            <a:off x="3502152" y="5330952"/>
-            <a:ext cx="420624" cy="420624"/>
+            <a:off x="3447288" y="5422392"/>
+            <a:ext cx="384048" cy="384048"/>
           </a:xfrm>
           <a:prstGeom prst="rect">
             <a:avLst/>
@@ -2022,9 +2033,9 @@
               <a:buNone/>
             </a:pPr>
             <a:r>
-              <a:rPr lang="en-US" sz="1600" b="1" dirty="0">
-                <a:solidFill>
-                  <a:srgbClr val="1F4E3D"/>
+              <a:rPr lang="en-US" sz="1500" b="1" dirty="0">
+                <a:solidFill>
+                  <a:srgbClr val="174769"/>
                 </a:solidFill>
                 <a:latin typeface="Calibri" pitchFamily="34" charset="0"/>
                 <a:ea typeface="Calibri" pitchFamily="34" charset="-122"/>
@@ -2032,7 +2043,7 @@
               </a:rPr>
               <a:t>2</a:t>
             </a:r>
-            <a:endParaRPr lang="en-US" sz="1600" dirty="0"/>
+            <a:endParaRPr lang="en-US" sz="1500" dirty="0"/>
           </a:p>
         </p:txBody>
       </p:sp>
@@ -2044,8 +2055,8 @@
         </p:nvSpPr>
         <p:spPr>
           <a:xfrm>
-            <a:off x="4032504" y="5221224"/>
-            <a:ext cx="2039112" cy="1005840"/>
+            <a:off x="3922776" y="5330952"/>
+            <a:ext cx="2121408" cy="1051560"/>
           </a:xfrm>
           <a:prstGeom prst="rect">
             <a:avLst/>
@@ -2061,7 +2072,7 @@
               <a:buNone/>
             </a:pPr>
             <a:r>
-              <a:rPr lang="en-US" sz="1300" dirty="0">
+              <a:rPr lang="en-US" sz="1250" dirty="0">
                 <a:solidFill>
                   <a:srgbClr val="FFFFFF"/>
                 </a:solidFill>
@@ -2069,9 +2080,9 @@
                 <a:ea typeface="Calibri" pitchFamily="34" charset="-122"/>
                 <a:cs typeface="Calibri" pitchFamily="34" charset="-120"/>
               </a:rPr>
-              <a:t>Automatyczna komunikacja od 1. dnia + reaktywacja uśpionych kont</a:t>
-            </a:r>
-            <a:endParaRPr lang="en-US" sz="1300" dirty="0"/>
+              <a:t>Program partnerski: punkty za zgody marketingowe i częstsze zamówienia</a:t>
+            </a:r>
+            <a:endParaRPr lang="en-US" sz="1250" dirty="0"/>
           </a:p>
         </p:txBody>
       </p:sp>
@@ -2083,18 +2094,18 @@
         </p:nvSpPr>
         <p:spPr>
           <a:xfrm>
-            <a:off x="6272784" y="5330952"/>
-            <a:ext cx="420624" cy="420624"/>
+            <a:off x="6208776" y="5422392"/>
+            <a:ext cx="384048" cy="384048"/>
           </a:xfrm>
           <a:prstGeom prst="ellipse">
             <a:avLst/>
           </a:prstGeom>
           <a:solidFill>
-            <a:srgbClr val="E0A100"/>
+            <a:srgbClr val="F8AF2D"/>
           </a:solidFill>
           <a:ln w="12700">
             <a:solidFill>
-              <a:srgbClr val="E0A100"/>
+              <a:srgbClr val="F8AF2D"/>
             </a:solidFill>
             <a:prstDash val="solid"/>
           </a:ln>
@@ -2108,8 +2119,8 @@
         </p:nvSpPr>
         <p:spPr>
           <a:xfrm>
-            <a:off x="6272784" y="5330952"/>
-            <a:ext cx="420624" cy="420624"/>
+            <a:off x="6208776" y="5422392"/>
+            <a:ext cx="384048" cy="384048"/>
           </a:xfrm>
           <a:prstGeom prst="rect">
             <a:avLst/>
@@ -2125,9 +2136,9 @@
               <a:buNone/>
             </a:pPr>
             <a:r>
-              <a:rPr lang="en-US" sz="1600" b="1" dirty="0">
-                <a:solidFill>
-                  <a:srgbClr val="1F4E3D"/>
+              <a:rPr lang="en-US" sz="1500" b="1" dirty="0">
+                <a:solidFill>
+                  <a:srgbClr val="174769"/>
                 </a:solidFill>
                 <a:latin typeface="Calibri" pitchFamily="34" charset="0"/>
                 <a:ea typeface="Calibri" pitchFamily="34" charset="-122"/>
@@ -2135,7 +2146,7 @@
               </a:rPr>
               <a:t>3</a:t>
             </a:r>
-            <a:endParaRPr lang="en-US" sz="1600" dirty="0"/>
+            <a:endParaRPr lang="en-US" sz="1500" dirty="0"/>
           </a:p>
         </p:txBody>
       </p:sp>
@@ -2147,8 +2158,8 @@
         </p:nvSpPr>
         <p:spPr>
           <a:xfrm>
-            <a:off x="6803136" y="5221224"/>
-            <a:ext cx="2039112" cy="1005840"/>
+            <a:off x="6684264" y="5330952"/>
+            <a:ext cx="2121408" cy="1051560"/>
           </a:xfrm>
           <a:prstGeom prst="rect">
             <a:avLst/>
@@ -2164,7 +2175,7 @@
               <a:buNone/>
             </a:pPr>
             <a:r>
-              <a:rPr lang="en-US" sz="1300" dirty="0">
+              <a:rPr lang="en-US" sz="1250" dirty="0">
                 <a:solidFill>
                   <a:srgbClr val="FFFFFF"/>
                 </a:solidFill>
@@ -2172,9 +2183,9 @@
                 <a:ea typeface="Calibri" pitchFamily="34" charset="-122"/>
                 <a:cs typeface="Calibri" pitchFamily="34" charset="-120"/>
               </a:rPr>
-              <a:t>Mniejsze, częstsze zamówienia: program lojalnościowy, rabat za szybszą płatność</a:t>
-            </a:r>
-            <a:endParaRPr lang="en-US" sz="1300" dirty="0"/>
+              <a:t>Prostszy panel + codzienny import z Sage: kwoty jak na fakturze, nr listu przewozowego</a:t>
+            </a:r>
+            <a:endParaRPr lang="en-US" sz="1250" dirty="0"/>
           </a:p>
         </p:txBody>
       </p:sp>
@@ -2186,18 +2197,18 @@
         </p:nvSpPr>
         <p:spPr>
           <a:xfrm>
-            <a:off x="9043416" y="5330952"/>
-            <a:ext cx="420624" cy="420624"/>
+            <a:off x="8970264" y="5422392"/>
+            <a:ext cx="384048" cy="384048"/>
           </a:xfrm>
           <a:prstGeom prst="ellipse">
             <a:avLst/>
           </a:prstGeom>
           <a:solidFill>
-            <a:srgbClr val="E0A100"/>
+            <a:srgbClr val="F8AF2D"/>
           </a:solidFill>
           <a:ln w="12700">
             <a:solidFill>
-              <a:srgbClr val="E0A100"/>
+              <a:srgbClr val="F8AF2D"/>
             </a:solidFill>
             <a:prstDash val="solid"/>
           </a:ln>
@@ -2211,8 +2222,8 @@
         </p:nvSpPr>
         <p:spPr>
           <a:xfrm>
-            <a:off x="9043416" y="5330952"/>
-            <a:ext cx="420624" cy="420624"/>
+            <a:off x="8970264" y="5422392"/>
+            <a:ext cx="384048" cy="384048"/>
           </a:xfrm>
           <a:prstGeom prst="rect">
             <a:avLst/>
@@ -2228,9 +2239,9 @@
               <a:buNone/>
             </a:pPr>
             <a:r>
-              <a:rPr lang="en-US" sz="1600" b="1" dirty="0">
-                <a:solidFill>
-                  <a:srgbClr val="1F4E3D"/>
+              <a:rPr lang="en-US" sz="1500" b="1" dirty="0">
+                <a:solidFill>
+                  <a:srgbClr val="174769"/>
                 </a:solidFill>
                 <a:latin typeface="Calibri" pitchFamily="34" charset="0"/>
                 <a:ea typeface="Calibri" pitchFamily="34" charset="-122"/>
@@ -2238,7 +2249,7 @@
               </a:rPr>
               <a:t>4</a:t>
             </a:r>
-            <a:endParaRPr lang="en-US" sz="1600" dirty="0"/>
+            <a:endParaRPr lang="en-US" sz="1500" dirty="0"/>
           </a:p>
         </p:txBody>
       </p:sp>
@@ -2250,8 +2261,8 @@
         </p:nvSpPr>
         <p:spPr>
           <a:xfrm>
-            <a:off x="9573768" y="5221224"/>
-            <a:ext cx="2039112" cy="1005840"/>
+            <a:off x="9445752" y="5330952"/>
+            <a:ext cx="2121408" cy="1051560"/>
           </a:xfrm>
           <a:prstGeom prst="rect">
             <a:avLst/>
@@ -2267,7 +2278,7 @@
               <a:buNone/>
             </a:pPr>
             <a:r>
-              <a:rPr lang="en-US" sz="1300" dirty="0">
+              <a:rPr lang="en-US" sz="1250" dirty="0">
                 <a:solidFill>
                   <a:srgbClr val="FFFFFF"/>
                 </a:solidFill>
@@ -2275,9 +2286,9 @@
                 <a:ea typeface="Calibri" pitchFamily="34" charset="-122"/>
                 <a:cs typeface="Calibri" pitchFamily="34" charset="-120"/>
               </a:rPr>
-              <a:t>Nowe sklepy także z lead genu (cold mailing), nie tylko z bazy przedstawicieli</a:t>
-            </a:r>
-            <a:endParaRPr lang="en-US" sz="1300" dirty="0"/>
+              <a:t>Liczymy konta, które zamawiają, i częstotliwość, nie rejestracje</a:t>
+            </a:r>
+            <a:endParaRPr lang="en-US" sz="1250" dirty="0"/>
           </a:p>
         </p:txBody>
       </p:sp>
@@ -2321,8 +2332,8 @@
         </p:nvSpPr>
         <p:spPr>
           <a:xfrm>
-            <a:off x="457200" y="320040"/>
-            <a:ext cx="11247120" cy="685800"/>
+            <a:off x="411480" y="274320"/>
+            <a:ext cx="11338560" cy="731520"/>
           </a:xfrm>
           <a:prstGeom prst="rect">
             <a:avLst/>
@@ -2338,15 +2349,93 @@
               <a:buNone/>
             </a:pPr>
             <a:r>
+              <a:rPr lang="en-US" sz="4000" b="1" dirty="0">
+                <a:solidFill>
+                  <a:srgbClr val="108C96"/>
+                </a:solidFill>
+                <a:latin typeface="Calibri" pitchFamily="34" charset="0"/>
+                <a:ea typeface="Calibri" pitchFamily="34" charset="-122"/>
+                <a:cs typeface="Calibri" pitchFamily="34" charset="-120"/>
+              </a:rPr>
+              <a:t>B2B PL – WYNIK I START FY27</a:t>
+            </a:r>
+            <a:endParaRPr lang="en-US" sz="4000" dirty="0"/>
+          </a:p>
+        </p:txBody>
+      </p:sp>
+      <p:sp>
+        <p:nvSpPr>
+          <p:cNvPr id="3" name="Text 1"/>
+          <p:cNvSpPr txBox="1"/>
+          <p:nvPr/>
+        </p:nvSpPr>
+        <p:spPr>
+          <a:xfrm>
+            <a:off x="411480" y="1143000"/>
+            <a:ext cx="6400800" cy="365760"/>
+          </a:xfrm>
+          <a:prstGeom prst="rect">
+            <a:avLst/>
+          </a:prstGeom>
+          <a:noFill/>
+          <a:ln/>
+        </p:spPr>
+        <p:txBody>
+          <a:bodyPr wrap="square" lIns="0" tIns="0" rIns="0" bIns="0" rtlCol="0" anchor="ctr"/>
+          <a:lstStyle/>
+          <a:p>
+            <a:pPr indent="0" marL="0">
+              <a:buNone/>
+            </a:pPr>
+            <a:r>
+              <a:rPr lang="en-US" sz="1600" b="1" dirty="0">
+                <a:solidFill>
+                  <a:srgbClr val="174769"/>
+                </a:solidFill>
+                <a:latin typeface="Calibri" pitchFamily="34" charset="0"/>
+                <a:ea typeface="Calibri" pitchFamily="34" charset="-122"/>
+                <a:cs typeface="Calibri" pitchFamily="34" charset="-120"/>
+              </a:rPr>
+              <a:t>Wynik FY26 vs budżet · stan na 25.08.2026</a:t>
+            </a:r>
+            <a:endParaRPr lang="en-US" sz="1600" dirty="0"/>
+          </a:p>
+        </p:txBody>
+      </p:sp>
+      <p:sp>
+        <p:nvSpPr>
+          <p:cNvPr id="4" name="Text 2"/>
+          <p:cNvSpPr txBox="1"/>
+          <p:nvPr/>
+        </p:nvSpPr>
+        <p:spPr>
+          <a:xfrm>
+            <a:off x="411480" y="1645920"/>
+            <a:ext cx="2697480" cy="502920"/>
+          </a:xfrm>
+          <a:prstGeom prst="rect">
+            <a:avLst/>
+          </a:prstGeom>
+          <a:noFill/>
+          <a:ln/>
+        </p:spPr>
+        <p:txBody>
+          <a:bodyPr wrap="square" lIns="0" tIns="0" rIns="0" bIns="0" rtlCol="0" anchor="b"/>
+          <a:lstStyle/>
+          <a:p>
+            <a:pPr indent="0" marL="0">
+              <a:buNone/>
+            </a:pPr>
+            <a:r>
               <a:rPr lang="en-US" sz="2800" b="1" dirty="0">
                 <a:solidFill>
-                  <a:srgbClr val="1F4E3D"/>
-                </a:solidFill>
-                <a:latin typeface="Cambria" pitchFamily="34" charset="0"/>
-                <a:ea typeface="Cambria" pitchFamily="34" charset="-122"/>
-                <a:cs typeface="Cambria" pitchFamily="34" charset="-120"/>
-              </a:rPr>
-              <a:t>B2B PL: wynik i nowy panel B2B</a:t>
+                  <a:srgbClr val="174769"/>
+                </a:solidFill>
+                <a:latin typeface="Calibri" pitchFamily="34" charset="0"/>
+                <a:ea typeface="Calibri" pitchFamily="34" charset="-122"/>
+                <a:cs typeface="Calibri" pitchFamily="34" charset="-120"/>
+              </a:rPr>
+              <a:t>396 757 €</a:t>
             </a:r>
             <a:endParaRPr lang="en-US" sz="2800" dirty="0"/>
           </a:p>
@@ -2354,14 +2443,14 @@
       </p:sp>
       <p:sp>
         <p:nvSpPr>
-          <p:cNvPr id="3" name="Text 1"/>
-          <p:cNvSpPr txBox="1"/>
-          <p:nvPr/>
-        </p:nvSpPr>
-        <p:spPr>
-          <a:xfrm>
-            <a:off x="457200" y="1143000"/>
-            <a:ext cx="6217920" cy="365760"/>
+          <p:cNvPr id="5" name="Text 3"/>
+          <p:cNvSpPr txBox="1"/>
+          <p:nvPr/>
+        </p:nvSpPr>
+        <p:spPr>
+          <a:xfrm>
+            <a:off x="411480" y="2157984"/>
+            <a:ext cx="2697480" cy="274320"/>
           </a:xfrm>
           <a:prstGeom prst="rect">
             <a:avLst/>
@@ -2377,87 +2466,9 @@
               <a:buNone/>
             </a:pPr>
             <a:r>
-              <a:rPr lang="en-US" sz="1600" b="1" dirty="0">
-                <a:solidFill>
-                  <a:srgbClr val="5E6B64"/>
-                </a:solidFill>
-                <a:latin typeface="Calibri" pitchFamily="34" charset="0"/>
-                <a:ea typeface="Calibri" pitchFamily="34" charset="-122"/>
-                <a:cs typeface="Calibri" pitchFamily="34" charset="-120"/>
-              </a:rPr>
-              <a:t>Wynik FY26 vs budżet · stan na 25.08.2026</a:t>
-            </a:r>
-            <a:endParaRPr lang="en-US" sz="1600" dirty="0"/>
-          </a:p>
-        </p:txBody>
-      </p:sp>
-      <p:sp>
-        <p:nvSpPr>
-          <p:cNvPr id="4" name="Text 2"/>
-          <p:cNvSpPr txBox="1"/>
-          <p:nvPr/>
-        </p:nvSpPr>
-        <p:spPr>
-          <a:xfrm>
-            <a:off x="457200" y="1645920"/>
-            <a:ext cx="2651760" cy="502920"/>
-          </a:xfrm>
-          <a:prstGeom prst="rect">
-            <a:avLst/>
-          </a:prstGeom>
-          <a:noFill/>
-          <a:ln/>
-        </p:spPr>
-        <p:txBody>
-          <a:bodyPr wrap="square" lIns="0" tIns="0" rIns="0" bIns="0" rtlCol="0" anchor="b"/>
-          <a:lstStyle/>
-          <a:p>
-            <a:pPr indent="0" marL="0">
-              <a:buNone/>
-            </a:pPr>
-            <a:r>
-              <a:rPr lang="en-US" sz="2800" b="1" dirty="0">
-                <a:solidFill>
-                  <a:srgbClr val="1E2A24"/>
-                </a:solidFill>
-                <a:latin typeface="Calibri" pitchFamily="34" charset="0"/>
-                <a:ea typeface="Calibri" pitchFamily="34" charset="-122"/>
-                <a:cs typeface="Calibri" pitchFamily="34" charset="-120"/>
-              </a:rPr>
-              <a:t>396 757 €</a:t>
-            </a:r>
-            <a:endParaRPr lang="en-US" sz="2800" dirty="0"/>
-          </a:p>
-        </p:txBody>
-      </p:sp>
-      <p:sp>
-        <p:nvSpPr>
-          <p:cNvPr id="5" name="Text 3"/>
-          <p:cNvSpPr txBox="1"/>
-          <p:nvPr/>
-        </p:nvSpPr>
-        <p:spPr>
-          <a:xfrm>
-            <a:off x="457200" y="2157984"/>
-            <a:ext cx="2651760" cy="274320"/>
-          </a:xfrm>
-          <a:prstGeom prst="rect">
-            <a:avLst/>
-          </a:prstGeom>
-          <a:noFill/>
-          <a:ln/>
-        </p:spPr>
-        <p:txBody>
-          <a:bodyPr wrap="square" lIns="0" tIns="0" rIns="0" bIns="0" rtlCol="0" anchor="ctr"/>
-          <a:lstStyle/>
-          <a:p>
-            <a:pPr indent="0" marL="0">
-              <a:buNone/>
-            </a:pPr>
-            <a:r>
               <a:rPr lang="en-US" sz="1200" dirty="0">
                 <a:solidFill>
-                  <a:srgbClr val="5E6B64"/>
+                  <a:srgbClr val="6B7F8E"/>
                 </a:solidFill>
                 <a:latin typeface="Calibri" pitchFamily="34" charset="0"/>
                 <a:ea typeface="Calibri" pitchFamily="34" charset="-122"/>
@@ -2477,7 +2488,7 @@
         </p:nvSpPr>
         <p:spPr>
           <a:xfrm>
-            <a:off x="3246120" y="1901952"/>
+            <a:off x="3200400" y="1901952"/>
             <a:ext cx="2743200" cy="237744"/>
           </a:xfrm>
           <a:prstGeom prst="roundRect">
@@ -2486,11 +2497,11 @@
             </a:avLst>
           </a:prstGeom>
           <a:solidFill>
-            <a:srgbClr val="D9E1DC"/>
+            <a:srgbClr val="E3ECEC"/>
           </a:solidFill>
           <a:ln w="12700">
             <a:solidFill>
-              <a:srgbClr val="D9E1DC"/>
+              <a:srgbClr val="E3ECEC"/>
             </a:solidFill>
             <a:prstDash val="solid"/>
           </a:ln>
@@ -2504,7 +2515,7 @@
         </p:nvSpPr>
         <p:spPr>
           <a:xfrm>
-            <a:off x="3246120" y="1901952"/>
+            <a:off x="3200400" y="1901952"/>
             <a:ext cx="2345655" cy="237744"/>
           </a:xfrm>
           <a:prstGeom prst="roundRect">
@@ -2513,11 +2524,11 @@
             </a:avLst>
           </a:prstGeom>
           <a:solidFill>
-            <a:srgbClr val="2E7D5B"/>
+            <a:srgbClr val="0E8B95"/>
           </a:solidFill>
           <a:ln w="12700">
             <a:solidFill>
-              <a:srgbClr val="2E7D5B"/>
+              <a:srgbClr val="0E8B95"/>
             </a:solidFill>
             <a:prstDash val="solid"/>
           </a:ln>
@@ -2531,8 +2542,8 @@
         </p:nvSpPr>
         <p:spPr>
           <a:xfrm>
-            <a:off x="6080760" y="1828800"/>
-            <a:ext cx="685800" cy="384048"/>
+            <a:off x="6035040" y="1828800"/>
+            <a:ext cx="731520" cy="384048"/>
           </a:xfrm>
           <a:prstGeom prst="rect">
             <a:avLst/>
@@ -2550,7 +2561,7 @@
             <a:r>
               <a:rPr lang="en-US" sz="1600" b="1" dirty="0">
                 <a:solidFill>
-                  <a:srgbClr val="2E7D5B"/>
+                  <a:srgbClr val="0E8B95"/>
                 </a:solidFill>
                 <a:latin typeface="Calibri" pitchFamily="34" charset="0"/>
                 <a:ea typeface="Calibri" pitchFamily="34" charset="-122"/>
@@ -2570,7 +2581,7 @@
         </p:nvSpPr>
         <p:spPr>
           <a:xfrm>
-            <a:off x="3246120" y="2176272"/>
+            <a:off x="3200400" y="2176272"/>
             <a:ext cx="3566160" cy="256032"/>
           </a:xfrm>
           <a:prstGeom prst="rect">
@@ -2589,7 +2600,7 @@
             <a:r>
               <a:rPr lang="en-US" sz="1100" dirty="0">
                 <a:solidFill>
-                  <a:srgbClr val="5E6B64"/>
+                  <a:srgbClr val="6B7F8E"/>
                 </a:solidFill>
                 <a:latin typeface="Calibri" pitchFamily="34" charset="0"/>
                 <a:ea typeface="Calibri" pitchFamily="34" charset="-122"/>
@@ -2609,8 +2620,8 @@
         </p:nvSpPr>
         <p:spPr>
           <a:xfrm>
-            <a:off x="457200" y="2560320"/>
-            <a:ext cx="2651760" cy="502920"/>
+            <a:off x="411480" y="2560320"/>
+            <a:ext cx="2697480" cy="502920"/>
           </a:xfrm>
           <a:prstGeom prst="rect">
             <a:avLst/>
@@ -2628,7 +2639,7 @@
             <a:r>
               <a:rPr lang="en-US" sz="2800" b="1" dirty="0">
                 <a:solidFill>
-                  <a:srgbClr val="1E2A24"/>
+                  <a:srgbClr val="174769"/>
                 </a:solidFill>
                 <a:latin typeface="Calibri" pitchFamily="34" charset="0"/>
                 <a:ea typeface="Calibri" pitchFamily="34" charset="-122"/>
@@ -2648,8 +2659,8 @@
         </p:nvSpPr>
         <p:spPr>
           <a:xfrm>
-            <a:off x="457200" y="3072384"/>
-            <a:ext cx="2651760" cy="274320"/>
+            <a:off x="411480" y="3072384"/>
+            <a:ext cx="2697480" cy="274320"/>
           </a:xfrm>
           <a:prstGeom prst="rect">
             <a:avLst/>
@@ -2667,7 +2678,7 @@
             <a:r>
               <a:rPr lang="en-US" sz="1200" dirty="0">
                 <a:solidFill>
-                  <a:srgbClr val="5E6B64"/>
+                  <a:srgbClr val="6B7F8E"/>
                 </a:solidFill>
                 <a:latin typeface="Calibri" pitchFamily="34" charset="0"/>
                 <a:ea typeface="Calibri" pitchFamily="34" charset="-122"/>
@@ -2687,7 +2698,7 @@
         </p:nvSpPr>
         <p:spPr>
           <a:xfrm>
-            <a:off x="3246120" y="2816352"/>
+            <a:off x="3200400" y="2816352"/>
             <a:ext cx="2743200" cy="237744"/>
           </a:xfrm>
           <a:prstGeom prst="roundRect">
@@ -2696,11 +2707,11 @@
             </a:avLst>
           </a:prstGeom>
           <a:solidFill>
-            <a:srgbClr val="D9E1DC"/>
+            <a:srgbClr val="E3ECEC"/>
           </a:solidFill>
           <a:ln w="12700">
             <a:solidFill>
-              <a:srgbClr val="D9E1DC"/>
+              <a:srgbClr val="E3ECEC"/>
             </a:solidFill>
             <a:prstDash val="solid"/>
           </a:ln>
@@ -2714,7 +2725,7 @@
         </p:nvSpPr>
         <p:spPr>
           <a:xfrm>
-            <a:off x="3246120" y="2816352"/>
+            <a:off x="3200400" y="2816352"/>
             <a:ext cx="2002221" cy="237744"/>
           </a:xfrm>
           <a:prstGeom prst="roundRect">
@@ -2723,11 +2734,11 @@
             </a:avLst>
           </a:prstGeom>
           <a:solidFill>
-            <a:srgbClr val="2E7D5B"/>
+            <a:srgbClr val="0E8B95"/>
           </a:solidFill>
           <a:ln w="12700">
             <a:solidFill>
-              <a:srgbClr val="2E7D5B"/>
+              <a:srgbClr val="0E8B95"/>
             </a:solidFill>
             <a:prstDash val="solid"/>
           </a:ln>
@@ -2741,8 +2752,8 @@
         </p:nvSpPr>
         <p:spPr>
           <a:xfrm>
-            <a:off x="6080760" y="2743200"/>
-            <a:ext cx="685800" cy="384048"/>
+            <a:off x="6035040" y="2743200"/>
+            <a:ext cx="731520" cy="384048"/>
           </a:xfrm>
           <a:prstGeom prst="rect">
             <a:avLst/>
@@ -2760,7 +2771,7 @@
             <a:r>
               <a:rPr lang="en-US" sz="1600" b="1" dirty="0">
                 <a:solidFill>
-                  <a:srgbClr val="2E7D5B"/>
+                  <a:srgbClr val="0E8B95"/>
                 </a:solidFill>
                 <a:latin typeface="Calibri" pitchFamily="34" charset="0"/>
                 <a:ea typeface="Calibri" pitchFamily="34" charset="-122"/>
@@ -2780,7 +2791,7 @@
         </p:nvSpPr>
         <p:spPr>
           <a:xfrm>
-            <a:off x="3246120" y="3090672"/>
+            <a:off x="3200400" y="3090672"/>
             <a:ext cx="3566160" cy="256032"/>
           </a:xfrm>
           <a:prstGeom prst="rect">
@@ -2799,7 +2810,7 @@
             <a:r>
               <a:rPr lang="en-US" sz="1100" dirty="0">
                 <a:solidFill>
-                  <a:srgbClr val="5E6B64"/>
+                  <a:srgbClr val="6B7F8E"/>
                 </a:solidFill>
                 <a:latin typeface="Calibri" pitchFamily="34" charset="0"/>
                 <a:ea typeface="Calibri" pitchFamily="34" charset="-122"/>
@@ -2819,8 +2830,8 @@
         </p:nvSpPr>
         <p:spPr>
           <a:xfrm>
-            <a:off x="457200" y="3474720"/>
-            <a:ext cx="2651760" cy="502920"/>
+            <a:off x="411480" y="3474720"/>
+            <a:ext cx="2697480" cy="502920"/>
           </a:xfrm>
           <a:prstGeom prst="rect">
             <a:avLst/>
@@ -2838,7 +2849,7 @@
             <a:r>
               <a:rPr lang="en-US" sz="2800" b="1" dirty="0">
                 <a:solidFill>
-                  <a:srgbClr val="1E2A24"/>
+                  <a:srgbClr val="174769"/>
                 </a:solidFill>
                 <a:latin typeface="Calibri" pitchFamily="34" charset="0"/>
                 <a:ea typeface="Calibri" pitchFamily="34" charset="-122"/>
@@ -2858,8 +2869,8 @@
         </p:nvSpPr>
         <p:spPr>
           <a:xfrm>
-            <a:off x="457200" y="3986784"/>
-            <a:ext cx="2651760" cy="274320"/>
+            <a:off x="411480" y="3986784"/>
+            <a:ext cx="2697480" cy="274320"/>
           </a:xfrm>
           <a:prstGeom prst="rect">
             <a:avLst/>
@@ -2877,7 +2888,7 @@
             <a:r>
               <a:rPr lang="en-US" sz="1200" dirty="0">
                 <a:solidFill>
-                  <a:srgbClr val="5E6B64"/>
+                  <a:srgbClr val="6B7F8E"/>
                 </a:solidFill>
                 <a:latin typeface="Calibri" pitchFamily="34" charset="0"/>
                 <a:ea typeface="Calibri" pitchFamily="34" charset="-122"/>
@@ -2897,7 +2908,7 @@
         </p:nvSpPr>
         <p:spPr>
           <a:xfrm>
-            <a:off x="3246120" y="3730752"/>
+            <a:off x="3200400" y="3730752"/>
             <a:ext cx="2743200" cy="237744"/>
           </a:xfrm>
           <a:prstGeom prst="roundRect">
@@ -2906,11 +2917,11 @@
             </a:avLst>
           </a:prstGeom>
           <a:solidFill>
-            <a:srgbClr val="D9E1DC"/>
+            <a:srgbClr val="E3ECEC"/>
           </a:solidFill>
           <a:ln w="12700">
             <a:solidFill>
-              <a:srgbClr val="D9E1DC"/>
+              <a:srgbClr val="E3ECEC"/>
             </a:solidFill>
             <a:prstDash val="solid"/>
           </a:ln>
@@ -2924,7 +2935,7 @@
         </p:nvSpPr>
         <p:spPr>
           <a:xfrm>
-            <a:off x="3246120" y="3730752"/>
+            <a:off x="3200400" y="3730752"/>
             <a:ext cx="910459" cy="237744"/>
           </a:xfrm>
           <a:prstGeom prst="roundRect">
@@ -2951,8 +2962,8 @@
         </p:nvSpPr>
         <p:spPr>
           <a:xfrm>
-            <a:off x="6080760" y="3657600"/>
-            <a:ext cx="685800" cy="384048"/>
+            <a:off x="6035040" y="3657600"/>
+            <a:ext cx="731520" cy="384048"/>
           </a:xfrm>
           <a:prstGeom prst="rect">
             <a:avLst/>
@@ -2990,7 +3001,7 @@
         </p:nvSpPr>
         <p:spPr>
           <a:xfrm>
-            <a:off x="3246120" y="4005072"/>
+            <a:off x="3200400" y="4005072"/>
             <a:ext cx="3566160" cy="256032"/>
           </a:xfrm>
           <a:prstGeom prst="rect">
@@ -3009,7 +3020,7 @@
             <a:r>
               <a:rPr lang="en-US" sz="1100" dirty="0">
                 <a:solidFill>
-                  <a:srgbClr val="5E6B64"/>
+                  <a:srgbClr val="6B7F8E"/>
                 </a:solidFill>
                 <a:latin typeface="Calibri" pitchFamily="34" charset="0"/>
                 <a:ea typeface="Calibri" pitchFamily="34" charset="-122"/>
@@ -3029,8 +3040,8 @@
         </p:nvSpPr>
         <p:spPr>
           <a:xfrm>
-            <a:off x="457200" y="4389120"/>
-            <a:ext cx="2651760" cy="502920"/>
+            <a:off x="411480" y="4389120"/>
+            <a:ext cx="2697480" cy="502920"/>
           </a:xfrm>
           <a:prstGeom prst="rect">
             <a:avLst/>
@@ -3048,7 +3059,7 @@
             <a:r>
               <a:rPr lang="en-US" sz="2800" b="1" dirty="0">
                 <a:solidFill>
-                  <a:srgbClr val="1E2A24"/>
+                  <a:srgbClr val="174769"/>
                 </a:solidFill>
                 <a:latin typeface="Calibri" pitchFamily="34" charset="0"/>
                 <a:ea typeface="Calibri" pitchFamily="34" charset="-122"/>
@@ -3068,8 +3079,8 @@
         </p:nvSpPr>
         <p:spPr>
           <a:xfrm>
-            <a:off x="457200" y="4901184"/>
-            <a:ext cx="2651760" cy="274320"/>
+            <a:off x="411480" y="4901184"/>
+            <a:ext cx="2697480" cy="274320"/>
           </a:xfrm>
           <a:prstGeom prst="rect">
             <a:avLst/>
@@ -3087,7 +3098,7 @@
             <a:r>
               <a:rPr lang="en-US" sz="1200" dirty="0">
                 <a:solidFill>
-                  <a:srgbClr val="5E6B64"/>
+                  <a:srgbClr val="6B7F8E"/>
                 </a:solidFill>
                 <a:latin typeface="Calibri" pitchFamily="34" charset="0"/>
                 <a:ea typeface="Calibri" pitchFamily="34" charset="-122"/>
@@ -3107,7 +3118,7 @@
         </p:nvSpPr>
         <p:spPr>
           <a:xfrm>
-            <a:off x="3246120" y="4645152"/>
+            <a:off x="3200400" y="4645152"/>
             <a:ext cx="2743200" cy="237744"/>
           </a:xfrm>
           <a:prstGeom prst="roundRect">
@@ -3116,11 +3127,11 @@
             </a:avLst>
           </a:prstGeom>
           <a:solidFill>
-            <a:srgbClr val="D9E1DC"/>
+            <a:srgbClr val="E3ECEC"/>
           </a:solidFill>
           <a:ln w="12700">
             <a:solidFill>
-              <a:srgbClr val="D9E1DC"/>
+              <a:srgbClr val="E3ECEC"/>
             </a:solidFill>
             <a:prstDash val="solid"/>
           </a:ln>
@@ -3134,7 +3145,7 @@
         </p:nvSpPr>
         <p:spPr>
           <a:xfrm>
-            <a:off x="3246120" y="4645152"/>
+            <a:off x="3200400" y="4645152"/>
             <a:ext cx="2743200" cy="237744"/>
           </a:xfrm>
           <a:prstGeom prst="roundRect">
@@ -3143,11 +3154,11 @@
             </a:avLst>
           </a:prstGeom>
           <a:solidFill>
-            <a:srgbClr val="E0A100"/>
+            <a:srgbClr val="F8AF2D"/>
           </a:solidFill>
           <a:ln w="12700">
             <a:solidFill>
-              <a:srgbClr val="E0A100"/>
+              <a:srgbClr val="F8AF2D"/>
             </a:solidFill>
             <a:prstDash val="solid"/>
           </a:ln>
@@ -3161,8 +3172,8 @@
         </p:nvSpPr>
         <p:spPr>
           <a:xfrm>
-            <a:off x="6080760" y="4572000"/>
-            <a:ext cx="685800" cy="384048"/>
+            <a:off x="6035040" y="4572000"/>
+            <a:ext cx="731520" cy="384048"/>
           </a:xfrm>
           <a:prstGeom prst="rect">
             <a:avLst/>
@@ -3180,7 +3191,7 @@
             <a:r>
               <a:rPr lang="en-US" sz="1600" b="1" dirty="0">
                 <a:solidFill>
-                  <a:srgbClr val="A87800"/>
+                  <a:srgbClr val="B7791F"/>
                 </a:solidFill>
                 <a:latin typeface="Calibri" pitchFamily="34" charset="0"/>
                 <a:ea typeface="Calibri" pitchFamily="34" charset="-122"/>
@@ -3200,7 +3211,7 @@
         </p:nvSpPr>
         <p:spPr>
           <a:xfrm>
-            <a:off x="3246120" y="4919472"/>
+            <a:off x="3200400" y="4919472"/>
             <a:ext cx="3566160" cy="256032"/>
           </a:xfrm>
           <a:prstGeom prst="rect">
@@ -3219,13 +3230,13 @@
             <a:r>
               <a:rPr lang="en-US" sz="1100" dirty="0">
                 <a:solidFill>
-                  <a:srgbClr val="5E6B64"/>
-                </a:solidFill>
-                <a:latin typeface="Calibri" pitchFamily="34" charset="0"/>
-                <a:ea typeface="Calibri" pitchFamily="34" charset="-122"/>
-                <a:cs typeface="Calibri" pitchFamily="34" charset="-120"/>
-              </a:rPr>
-              <a:t>plan 500 €</a:t>
+                  <a:srgbClr val="6B7F8E"/>
+                </a:solidFill>
+                <a:latin typeface="Calibri" pitchFamily="34" charset="0"/>
+                <a:ea typeface="Calibri" pitchFamily="34" charset="-122"/>
+                <a:cs typeface="Calibri" pitchFamily="34" charset="-120"/>
+              </a:rPr>
+              <a:t>plan 500 € (2,6×)</a:t>
             </a:r>
             <a:endParaRPr lang="en-US" sz="1100" dirty="0"/>
           </a:p>
@@ -3239,20 +3250,18 @@
         </p:nvSpPr>
         <p:spPr>
           <a:xfrm>
-            <a:off x="457200" y="5440680"/>
-            <a:ext cx="6263640" cy="777240"/>
-          </a:xfrm>
-          <a:prstGeom prst="roundRect">
-            <a:avLst>
-              <a:gd name="adj" fmla="val 9412"/>
-            </a:avLst>
-          </a:prstGeom>
-          <a:solidFill>
-            <a:srgbClr val="EEF4F0"/>
+            <a:off x="411480" y="5440680"/>
+            <a:ext cx="6355080" cy="777240"/>
+          </a:xfrm>
+          <a:prstGeom prst="rect">
+            <a:avLst/>
+          </a:prstGeom>
+          <a:solidFill>
+            <a:srgbClr val="DAEBEA"/>
           </a:solidFill>
           <a:ln w="12700">
             <a:solidFill>
-              <a:srgbClr val="EEF4F0"/>
+              <a:srgbClr val="00676D"/>
             </a:solidFill>
             <a:prstDash val="solid"/>
           </a:ln>
@@ -3266,8 +3275,8 @@
         </p:nvSpPr>
         <p:spPr>
           <a:xfrm>
-            <a:off x="640080" y="5440680"/>
-            <a:ext cx="5943600" cy="777240"/>
+            <a:off x="594360" y="5440680"/>
+            <a:ext cx="6035040" cy="777240"/>
           </a:xfrm>
           <a:prstGeom prst="rect">
             <a:avLst/>
@@ -3285,7 +3294,7 @@
             <a:r>
               <a:rPr lang="en-US" sz="1300" b="1" dirty="0">
                 <a:solidFill>
-                  <a:srgbClr val="1F4E3D"/>
+                  <a:srgbClr val="174769"/>
                 </a:solidFill>
                 <a:latin typeface="Calibri" pitchFamily="34" charset="0"/>
                 <a:ea typeface="Calibri" pitchFamily="34" charset="-122"/>
@@ -3299,7 +3308,7 @@
             <a:r>
               <a:rPr lang="en-US" sz="1300" dirty="0">
                 <a:solidFill>
-                  <a:srgbClr val="1E2A24"/>
+                  <a:srgbClr val="30597A"/>
                 </a:solidFill>
                 <a:latin typeface="Calibri" pitchFamily="34" charset="0"/>
                 <a:ea typeface="Calibri" pitchFamily="34" charset="-122"/>
@@ -3320,19 +3329,17 @@
         <p:spPr>
           <a:xfrm>
             <a:off x="7086600" y="1143000"/>
-            <a:ext cx="4645152" cy="5074920"/>
-          </a:xfrm>
-          <a:prstGeom prst="roundRect">
-            <a:avLst>
-              <a:gd name="adj" fmla="val 1575"/>
-            </a:avLst>
-          </a:prstGeom>
-          <a:solidFill>
-            <a:srgbClr val="1F4E3D"/>
+            <a:ext cx="4663440" cy="5074920"/>
+          </a:xfrm>
+          <a:prstGeom prst="rect">
+            <a:avLst/>
+          </a:prstGeom>
+          <a:solidFill>
+            <a:srgbClr val="174769"/>
           </a:solidFill>
           <a:ln w="12700">
             <a:solidFill>
-              <a:srgbClr val="1F4E3D"/>
+              <a:srgbClr val="174769"/>
             </a:solidFill>
             <a:prstDash val="solid"/>
           </a:ln>
@@ -3346,8 +3353,8 @@
         </p:nvSpPr>
         <p:spPr>
           <a:xfrm>
-            <a:off x="7360920" y="1371600"/>
-            <a:ext cx="4096512" cy="411480"/>
+            <a:off x="7360920" y="1344168"/>
+            <a:ext cx="4114800" cy="365760"/>
           </a:xfrm>
           <a:prstGeom prst="rect">
             <a:avLst/>
@@ -3365,13 +3372,13 @@
             <a:r>
               <a:rPr lang="en-US" sz="1800" b="1" dirty="0">
                 <a:solidFill>
-                  <a:srgbClr val="FFFFFF"/>
-                </a:solidFill>
-                <a:latin typeface="Cambria" pitchFamily="34" charset="0"/>
-                <a:ea typeface="Cambria" pitchFamily="34" charset="-122"/>
-                <a:cs typeface="Cambria" pitchFamily="34" charset="-120"/>
-              </a:rPr>
-              <a:t>Nowy panel B2B</a:t>
+                  <a:srgbClr val="F8AF2D"/>
+                </a:solidFill>
+                <a:latin typeface="Calibri" pitchFamily="34" charset="0"/>
+                <a:ea typeface="Calibri" pitchFamily="34" charset="-122"/>
+                <a:cs typeface="Calibri" pitchFamily="34" charset="-120"/>
+              </a:rPr>
+              <a:t>NOWA PLATFORMA B2B</a:t>
             </a:r>
             <a:endParaRPr lang="en-US" sz="1800" dirty="0"/>
           </a:p>
@@ -3385,8 +3392,8 @@
         </p:nvSpPr>
         <p:spPr>
           <a:xfrm>
-            <a:off x="7360920" y="1783080"/>
-            <a:ext cx="4096512" cy="274320"/>
+            <a:off x="7360920" y="1709928"/>
+            <a:ext cx="4114800" cy="457200"/>
           </a:xfrm>
           <a:prstGeom prst="rect">
             <a:avLst/>
@@ -3404,13 +3411,13 @@
             <a:r>
               <a:rPr lang="en-US" sz="1200" i="1" dirty="0">
                 <a:solidFill>
-                  <a:srgbClr val="BFD8CC"/>
-                </a:solidFill>
-                <a:latin typeface="Calibri" pitchFamily="34" charset="0"/>
-                <a:ea typeface="Calibri" pitchFamily="34" charset="-122"/>
-                <a:cs typeface="Calibri" pitchFamily="34" charset="-120"/>
-              </a:rPr>
-              <a:t>sbm-sales.site · odpowiada na learningi z FY26</a:t>
+                  <a:srgbClr val="C9DCE8"/>
+                </a:solidFill>
+                <a:latin typeface="Calibri" pitchFamily="34" charset="0"/>
+                <a:ea typeface="Calibri" pitchFamily="34" charset="-122"/>
+                <a:cs typeface="Calibri" pitchFamily="34" charset="-120"/>
+              </a:rPr>
+              <a:t>start 1.10.2026 · stary panel sbm-partners.com działa równolegle do 30.10</a:t>
             </a:r>
             <a:endParaRPr lang="en-US" sz="1200" dirty="0"/>
           </a:p>
@@ -3432,8 +3439,8 @@
         </p:blipFill>
         <p:spPr>
           <a:xfrm>
-            <a:off x="7360920" y="2267712"/>
-            <a:ext cx="256032" cy="256032"/>
+            <a:off x="7360920" y="2359152"/>
+            <a:ext cx="237744" cy="237744"/>
           </a:xfrm>
           <a:prstGeom prst="rect">
             <a:avLst/>
@@ -3448,8 +3455,8 @@
         </p:nvSpPr>
         <p:spPr>
           <a:xfrm>
-            <a:off x="7744968" y="2240280"/>
-            <a:ext cx="3776472" cy="685800"/>
+            <a:off x="7726680" y="2331720"/>
+            <a:ext cx="3840480" cy="685800"/>
           </a:xfrm>
           <a:prstGeom prst="rect">
             <a:avLst/>
@@ -3473,7 +3480,7 @@
                 <a:ea typeface="Calibri" pitchFamily="34" charset="-122"/>
                 <a:cs typeface="Calibri" pitchFamily="34" charset="-120"/>
               </a:rPr>
-              <a:t>Ceny netto już z rabatem klienta</a:t>
+              <a:t>Ceny netto z rabatem klienta</a:t>
             </a:r>
             <a:endParaRPr lang="en-US" sz="1400" dirty="0"/>
           </a:p>
@@ -3484,13 +3491,13 @@
             <a:r>
               <a:rPr lang="en-US" sz="1200" dirty="0">
                 <a:solidFill>
-                  <a:srgbClr val="D5E6DD"/>
-                </a:solidFill>
-                <a:latin typeface="Calibri" pitchFamily="34" charset="0"/>
-                <a:ea typeface="Calibri" pitchFamily="34" charset="-122"/>
-                <a:cs typeface="Calibri" pitchFamily="34" charset="-120"/>
-              </a:rPr>
-              <a:t>to, co w koszyku, jest na fakturze</a:t>
+                  <a:srgbClr val="D5E3EC"/>
+                </a:solidFill>
+                <a:latin typeface="Calibri" pitchFamily="34" charset="0"/>
+                <a:ea typeface="Calibri" pitchFamily="34" charset="-122"/>
+                <a:cs typeface="Calibri" pitchFamily="34" charset="-120"/>
+              </a:rPr>
+              <a:t>kwota w koszyku = kwota na fakturze</a:t>
             </a:r>
             <a:endParaRPr lang="en-US" sz="1400" dirty="0"/>
           </a:p>
@@ -3512,8 +3519,8 @@
         </p:blipFill>
         <p:spPr>
           <a:xfrm>
-            <a:off x="7360920" y="3035808"/>
-            <a:ext cx="256032" cy="256032"/>
+            <a:off x="7360920" y="3108960"/>
+            <a:ext cx="237744" cy="237744"/>
           </a:xfrm>
           <a:prstGeom prst="rect">
             <a:avLst/>
@@ -3528,8 +3535,8 @@
         </p:nvSpPr>
         <p:spPr>
           <a:xfrm>
-            <a:off x="7744968" y="3008376"/>
-            <a:ext cx="3776472" cy="685800"/>
+            <a:off x="7726680" y="3081528"/>
+            <a:ext cx="3840480" cy="685800"/>
           </a:xfrm>
           <a:prstGeom prst="rect">
             <a:avLst/>
@@ -3564,13 +3571,13 @@
             <a:r>
               <a:rPr lang="en-US" sz="1200" dirty="0">
                 <a:solidFill>
-                  <a:srgbClr val="D5E6DD"/>
-                </a:solidFill>
-                <a:latin typeface="Calibri" pitchFamily="34" charset="0"/>
-                <a:ea typeface="Calibri" pitchFamily="34" charset="-122"/>
-                <a:cs typeface="Calibri" pitchFamily="34" charset="-120"/>
-              </a:rPr>
-              <a:t>zamiast przedpłaty, np. 14 dni</a:t>
+                  <a:srgbClr val="D5E3EC"/>
+                </a:solidFill>
+                <a:latin typeface="Calibri" pitchFamily="34" charset="0"/>
+                <a:ea typeface="Calibri" pitchFamily="34" charset="-122"/>
+                <a:cs typeface="Calibri" pitchFamily="34" charset="-120"/>
+              </a:rPr>
+              <a:t>termin płatności w koszyku: krótszy = taniej</a:t>
             </a:r>
             <a:endParaRPr lang="en-US" sz="1400" dirty="0"/>
           </a:p>
@@ -3592,8 +3599,8 @@
         </p:blipFill>
         <p:spPr>
           <a:xfrm>
-            <a:off x="7360920" y="3803904"/>
-            <a:ext cx="256032" cy="256032"/>
+            <a:off x="7360920" y="3858768"/>
+            <a:ext cx="237744" cy="237744"/>
           </a:xfrm>
           <a:prstGeom prst="rect">
             <a:avLst/>
@@ -3608,8 +3615,8 @@
         </p:nvSpPr>
         <p:spPr>
           <a:xfrm>
-            <a:off x="7744968" y="3776472"/>
-            <a:ext cx="3776472" cy="685800"/>
+            <a:off x="7726680" y="3831336"/>
+            <a:ext cx="3840480" cy="685800"/>
           </a:xfrm>
           <a:prstGeom prst="rect">
             <a:avLst/>
@@ -3633,7 +3640,7 @@
                 <a:ea typeface="Calibri" pitchFamily="34" charset="-122"/>
                 <a:cs typeface="Calibri" pitchFamily="34" charset="-120"/>
               </a:rPr>
-              <a:t>Termin płatności w koszyku</a:t>
+              <a:t>Zamówienie w 4 krokach</a:t>
             </a:r>
             <a:endParaRPr lang="en-US" sz="1400" dirty="0"/>
           </a:p>
@@ -3644,13 +3651,13 @@
             <a:r>
               <a:rPr lang="en-US" sz="1200" dirty="0">
                 <a:solidFill>
-                  <a:srgbClr val="D5E6DD"/>
-                </a:solidFill>
-                <a:latin typeface="Calibri" pitchFamily="34" charset="0"/>
-                <a:ea typeface="Calibri" pitchFamily="34" charset="-122"/>
-                <a:cs typeface="Calibri" pitchFamily="34" charset="-120"/>
-              </a:rPr>
-              <a:t>krótszy termin = niższa cena od razu</a:t>
+                  <a:srgbClr val="D5E3EC"/>
+                </a:solidFill>
+                <a:latin typeface="Calibri" pitchFamily="34" charset="0"/>
+                <a:ea typeface="Calibri" pitchFamily="34" charset="-122"/>
+                <a:cs typeface="Calibri" pitchFamily="34" charset="-120"/>
+              </a:rPr>
+              <a:t>katalog, ilość, płatność, data; także na telefonie</a:t>
             </a:r>
             <a:endParaRPr lang="en-US" sz="1400" dirty="0"/>
           </a:p>
@@ -3672,8 +3679,8 @@
         </p:blipFill>
         <p:spPr>
           <a:xfrm>
-            <a:off x="7360920" y="4572000"/>
-            <a:ext cx="256032" cy="256032"/>
+            <a:off x="7360920" y="4608576"/>
+            <a:ext cx="237744" cy="237744"/>
           </a:xfrm>
           <a:prstGeom prst="rect">
             <a:avLst/>
@@ -3688,8 +3695,8 @@
         </p:nvSpPr>
         <p:spPr>
           <a:xfrm>
-            <a:off x="7744968" y="4544568"/>
-            <a:ext cx="3776472" cy="685800"/>
+            <a:off x="7726680" y="4581144"/>
+            <a:ext cx="3840480" cy="685800"/>
           </a:xfrm>
           <a:prstGeom prst="rect">
             <a:avLst/>
@@ -3713,7 +3720,7 @@
                 <a:ea typeface="Calibri" pitchFamily="34" charset="-122"/>
                 <a:cs typeface="Calibri" pitchFamily="34" charset="-120"/>
               </a:rPr>
-              <a:t>Zamówienie w 4 krokach</a:t>
+              <a:t>Automatyczne maile do klienta</a:t>
             </a:r>
             <a:endParaRPr lang="en-US" sz="1400" dirty="0"/>
           </a:p>
@@ -3724,13 +3731,13 @@
             <a:r>
               <a:rPr lang="en-US" sz="1200" dirty="0">
                 <a:solidFill>
-                  <a:srgbClr val="D5E6DD"/>
-                </a:solidFill>
-                <a:latin typeface="Calibri" pitchFamily="34" charset="0"/>
-                <a:ea typeface="Calibri" pitchFamily="34" charset="-122"/>
-                <a:cs typeface="Calibri" pitchFamily="34" charset="-120"/>
-              </a:rPr>
-              <a:t>katalog, ilość, płatność, data; działa też na telefonie</a:t>
+                  <a:srgbClr val="D5E3EC"/>
+                </a:solidFill>
+                <a:latin typeface="Calibri" pitchFamily="34" charset="0"/>
+                <a:ea typeface="Calibri" pitchFamily="34" charset="-122"/>
+                <a:cs typeface="Calibri" pitchFamily="34" charset="-120"/>
+              </a:rPr>
+              <a:t>aktywacja konta, 1. zamówienie, potwierdzenia</a:t>
             </a:r>
             <a:endParaRPr lang="en-US" sz="1400" dirty="0"/>
           </a:p>
@@ -3752,8 +3759,8 @@
         </p:blipFill>
         <p:spPr>
           <a:xfrm>
-            <a:off x="7360920" y="5340096"/>
-            <a:ext cx="256032" cy="256032"/>
+            <a:off x="7360920" y="5358384"/>
+            <a:ext cx="237744" cy="237744"/>
           </a:xfrm>
           <a:prstGeom prst="rect">
             <a:avLst/>
@@ -3768,8 +3775,8 @@
         </p:nvSpPr>
         <p:spPr>
           <a:xfrm>
-            <a:off x="7744968" y="5312664"/>
-            <a:ext cx="3776472" cy="685800"/>
+            <a:off x="7726680" y="5330952"/>
+            <a:ext cx="3840480" cy="685800"/>
           </a:xfrm>
           <a:prstGeom prst="rect">
             <a:avLst/>
@@ -3793,7 +3800,7 @@
                 <a:ea typeface="Calibri" pitchFamily="34" charset="-122"/>
                 <a:cs typeface="Calibri" pitchFamily="34" charset="-120"/>
               </a:rPr>
-              <a:t>Automatyczne maile do klienta</a:t>
+              <a:t>Program partnerski od 1.10</a:t>
             </a:r>
             <a:endParaRPr lang="en-US" sz="1400" dirty="0"/>
           </a:p>
@@ -3804,13 +3811,13 @@
             <a:r>
               <a:rPr lang="en-US" sz="1200" dirty="0">
                 <a:solidFill>
-                  <a:srgbClr val="D5E6DD"/>
-                </a:solidFill>
-                <a:latin typeface="Calibri" pitchFamily="34" charset="0"/>
-                <a:ea typeface="Calibri" pitchFamily="34" charset="-122"/>
-                <a:cs typeface="Calibri" pitchFamily="34" charset="-120"/>
-              </a:rPr>
-              <a:t>aktywacja konta, instrukcja 1. zamówienia, potwierdzenia</a:t>
+                  <a:srgbClr val="D5E3EC"/>
+                </a:solidFill>
+                <a:latin typeface="Calibri" pitchFamily="34" charset="0"/>
+                <a:ea typeface="Calibri" pitchFamily="34" charset="-122"/>
+                <a:cs typeface="Calibri" pitchFamily="34" charset="-120"/>
+              </a:rPr>
+              <a:t>wersja ręczna, silnik i integracja w Q4</a:t>
             </a:r>
             <a:endParaRPr lang="en-US" sz="1400" dirty="0"/>
           </a:p>
@@ -3824,8 +3831,8 @@
         </p:nvSpPr>
         <p:spPr>
           <a:xfrm>
-            <a:off x="457200" y="6355080"/>
-            <a:ext cx="11247120" cy="274320"/>
+            <a:off x="411480" y="6355080"/>
+            <a:ext cx="11338560" cy="274320"/>
           </a:xfrm>
           <a:prstGeom prst="rect">
             <a:avLst/>
@@ -3843,13 +3850,13 @@
             <a:r>
               <a:rPr lang="en-US" sz="1000" dirty="0">
                 <a:solidFill>
-                  <a:srgbClr val="5E6B64"/>
-                </a:solidFill>
-                <a:latin typeface="Calibri" pitchFamily="34" charset="0"/>
-                <a:ea typeface="Calibri" pitchFamily="34" charset="-122"/>
-                <a:cs typeface="Calibri" pitchFamily="34" charset="-120"/>
-              </a:rPr>
-              <a:t>Dane: raport KPI B2B z 25.08.2026 (Sage ZORDDET, WEB-B2B, narastająco). Nowy panel: funkcje na podstawie testów, wrzesień 2026.</a:t>
+                  <a:srgbClr val="6B7F8E"/>
+                </a:solidFill>
+                <a:latin typeface="Calibri" pitchFamily="34" charset="0"/>
+                <a:ea typeface="Calibri" pitchFamily="34" charset="-122"/>
+                <a:cs typeface="Calibri" pitchFamily="34" charset="-120"/>
+              </a:rPr>
+              <a:t>Dane: raport KPI B2B z 25.08.2026 (Sage ZORDDET, WEB-B2B, narastająco). 59% powrotów: Sage ZORDDET 16.03–22.07.2026.</a:t>
             </a:r>
             <a:endParaRPr lang="en-US" sz="1000" dirty="0"/>
           </a:p>

</xml_diff>

<commit_message>
Add panel orders 323-331 (26.08-25.09) to B2B result; plan wording follows the numbers
Co-Authored-By: Claude Opus 5.5 <noreply@anthropic.com>
Claude-Session: https://claude.ai/code/session_01X3b4nN4VQ8Ge4ucA4qFPyi
</commit_message>
<xml_diff>
--- a/B2B_PL_kickoff_FY27_2_slajdy.pptx
+++ b/B2B_PL_kickoff_FY27_2_slajdy.pptx
@@ -503,7 +503,7 @@
           <a:p>
             <a:r>
               <a:rPr lang="en-US" dirty="0"/>
-              <a:t>Jeden slajd zamiast angielskich slajdów o panelu B2B. Założenia z business case FY26: 166 klientów, 928 zamówień, 464 tys. €. Panel się przyjął: 174 kont, 86% budżetu sprzedaży i przed planem do dziś, 59% klientów wraca z drugim zamówieniem. Słabo z liczbą zamówień (308 = 33% celu): klienci zamawiają rzadko i dużo, bez kampanii, bez kontaktu w sezonie, a korekty cen w Sage nie wracały do panelu. Stąd 4 learningi na FY27.</a:t>
+              <a:t>Jeden slajd zamiast angielskich slajdów o panelu B2B. Założenia z business case FY26: 166 klientów, 928 zamówień, 464 tys. €. Panel się przyjął: 174 kont, 91% budżetu sprzedaży (94% planu do dziś), 59% klientów wraca z drugim zamówieniem. Słabo z liczbą zamówień (317 = 34% celu): klienci zamawiają rzadko i dużo, bez kampanii, bez kontaktu w sezonie, a korekty cen w Sage nie wracały do panelu. Stąd 4 learningi na FY27.</a:t>
             </a:r>
             <a:endParaRPr lang="en-US" dirty="0"/>
           </a:p>
@@ -591,7 +591,7 @@
           <a:p>
             <a:r>
               <a:rPr lang="en-US" dirty="0"/>
-              <a:t>Wynik na 25.08.2026: 86% budżetu sprzedaży (105% planu do dziś), 73% kont z zamówieniem, ale tylko 33% celu zamówień. Średnie zamówienie 2,6× plan, bo klienci zamawiają rzadko i dużo. 1 października startuje nowa platforma: ceny i rabaty od razu w koszyku, kredyt kupiecki, rabat za krótszy termin płatności, automatyczne maile i program partnerski. Cele FY27: 900 tys. €, 1 125 zamówień.</a:t>
+              <a:t>Wynik na 25.09.2026: 91% budżetu sprzedaży (94% planu do dziś), 73% kont z zamówieniem, ale tylko 34% celu zamówień. Średnie zamówienie 2,7× plan, bo klienci zamawiają rzadko i dużo. 1 października startuje nowa platforma: ceny i rabaty od razu w koszyku, kredyt kupiecki, rabat za krótszy termin płatności, automatyczne maile i program partnerski. Cele FY27: 900 tys. €, 1 125 zamówień.</a:t>
             </a:r>
             <a:endParaRPr lang="en-US" dirty="0"/>
           </a:p>
@@ -1549,7 +1549,7 @@
                 <a:ea typeface="Calibri" pitchFamily="34" charset="-122"/>
                 <a:cs typeface="Calibri" pitchFamily="34" charset="-120"/>
               </a:rPr>
-              <a:t>396,8 tys. € = 86% budżetu, 105% planu do dziś</a:t>
+              <a:t>422,4 tys. € = 91% budżetu, 94% planu do dziś</a:t>
             </a:r>
             <a:endParaRPr lang="en-US" sz="1250" dirty="0"/>
           </a:p>
@@ -1747,7 +1747,7 @@
                 <a:ea typeface="Calibri" pitchFamily="34" charset="-122"/>
                 <a:cs typeface="Calibri" pitchFamily="34" charset="-120"/>
               </a:rPr>
-              <a:t>308 zamówień = 33% celu: rzadkie, duże zamówienia „na stock”</a:t>
+              <a:t>317 zamówień = 34% celu: rzadkie, duże zamówienia „na stock”</a:t>
             </a:r>
             <a:endParaRPr lang="en-US" sz="1250" dirty="0"/>
           </a:p>
@@ -2396,7 +2396,7 @@
                 <a:ea typeface="Calibri" pitchFamily="34" charset="-122"/>
                 <a:cs typeface="Calibri" pitchFamily="34" charset="-120"/>
               </a:rPr>
-              <a:t>Wynik FY26 vs budżet · stan na 25.08.2026</a:t>
+              <a:t>Wynik FY26 vs budżet · stan na 25.09.2026</a:t>
             </a:r>
             <a:endParaRPr lang="en-US" sz="1600" dirty="0"/>
           </a:p>
@@ -2435,7 +2435,7 @@
                 <a:ea typeface="Calibri" pitchFamily="34" charset="-122"/>
                 <a:cs typeface="Calibri" pitchFamily="34" charset="-120"/>
               </a:rPr>
-              <a:t>396 757 €</a:t>
+              <a:t>422 418 €</a:t>
             </a:r>
             <a:endParaRPr lang="en-US" sz="2800" dirty="0"/>
           </a:p>
@@ -2516,7 +2516,7 @@
         <p:spPr>
           <a:xfrm>
             <a:off x="3200400" y="1901952"/>
-            <a:ext cx="2345655" cy="237744"/>
+            <a:ext cx="2497364" cy="237744"/>
           </a:xfrm>
           <a:prstGeom prst="roundRect">
             <a:avLst>
@@ -2567,7 +2567,7 @@
                 <a:ea typeface="Calibri" pitchFamily="34" charset="-122"/>
                 <a:cs typeface="Calibri" pitchFamily="34" charset="-120"/>
               </a:rPr>
-              <a:t>86%</a:t>
+              <a:t>91%</a:t>
             </a:r>
             <a:endParaRPr lang="en-US" sz="1600" dirty="0"/>
           </a:p>
@@ -2606,7 +2606,7 @@
                 <a:ea typeface="Calibri" pitchFamily="34" charset="-122"/>
                 <a:cs typeface="Calibri" pitchFamily="34" charset="-120"/>
               </a:rPr>
-              <a:t>budżet 464 000 € · 105% planu do dziś</a:t>
+              <a:t>budżet 464 000 € · 94% planu do dziś</a:t>
             </a:r>
             <a:endParaRPr lang="en-US" sz="1100" dirty="0"/>
           </a:p>
@@ -2855,7 +2855,7 @@
                 <a:ea typeface="Calibri" pitchFamily="34" charset="-122"/>
                 <a:cs typeface="Calibri" pitchFamily="34" charset="-120"/>
               </a:rPr>
-              <a:t>308</a:t>
+              <a:t>317</a:t>
             </a:r>
             <a:endParaRPr lang="en-US" sz="2800" dirty="0"/>
           </a:p>
@@ -2936,7 +2936,7 @@
         <p:spPr>
           <a:xfrm>
             <a:off x="3200400" y="3730752"/>
-            <a:ext cx="910459" cy="237744"/>
+            <a:ext cx="937063" cy="237744"/>
           </a:xfrm>
           <a:prstGeom prst="roundRect">
             <a:avLst>
@@ -2987,7 +2987,7 @@
                 <a:ea typeface="Calibri" pitchFamily="34" charset="-122"/>
                 <a:cs typeface="Calibri" pitchFamily="34" charset="-120"/>
               </a:rPr>
-              <a:t>33%</a:t>
+              <a:t>34%</a:t>
             </a:r>
             <a:endParaRPr lang="en-US" sz="1600" dirty="0"/>
           </a:p>
@@ -3065,7 +3065,7 @@
                 <a:ea typeface="Calibri" pitchFamily="34" charset="-122"/>
                 <a:cs typeface="Calibri" pitchFamily="34" charset="-120"/>
               </a:rPr>
-              <a:t>1 288 €</a:t>
+              <a:t>1 333 €</a:t>
             </a:r>
             <a:endParaRPr lang="en-US" sz="2800" dirty="0"/>
           </a:p>
@@ -3197,7 +3197,7 @@
                 <a:ea typeface="Calibri" pitchFamily="34" charset="-122"/>
                 <a:cs typeface="Calibri" pitchFamily="34" charset="-120"/>
               </a:rPr>
-              <a:t>258%</a:t>
+              <a:t>267%</a:t>
             </a:r>
             <a:endParaRPr lang="en-US" sz="1600" dirty="0"/>
           </a:p>
@@ -3236,7 +3236,7 @@
                 <a:ea typeface="Calibri" pitchFamily="34" charset="-122"/>
                 <a:cs typeface="Calibri" pitchFamily="34" charset="-120"/>
               </a:rPr>
-              <a:t>plan 500 € (2,6×)</a:t>
+              <a:t>plan 500 € (2,7×)</a:t>
             </a:r>
             <a:endParaRPr lang="en-US" sz="1100" dirty="0"/>
           </a:p>
@@ -3856,7 +3856,7 @@
                 <a:ea typeface="Calibri" pitchFamily="34" charset="-122"/>
                 <a:cs typeface="Calibri" pitchFamily="34" charset="-120"/>
               </a:rPr>
-              <a:t>Dane: raport KPI B2B z 25.08.2026 (Sage ZORDDET, WEB-B2B, narastająco). 59% powrotów: Sage ZORDDET 16.03–22.07.2026.</a:t>
+              <a:t>Dane: raport KPI B2B z 25.08.2026 (Sage ZORDDET, WEB-B2B, narastająco) + nowe zamówienia z panelu sbm-partners.com 26.08–25.09.2026. 59% powrotów: Sage ZORDDET 16.03–22.07.2026.</a:t>
             </a:r>
             <a:endParaRPr lang="en-US" sz="1000" dirty="0"/>
           </a:p>

</xml_diff>